<commit_message>
course(specification): 15 deck fixes + new Sleep Advisor running-example slide
Specification lecture deck (1-5-Specification.pptx):
- 15 mechanical/nit fixes: slide-2 line break, notes rewrites (slides 3/4/9/
  10/11/12/13/15 notes), slide-7 prompts, slide-12 FULL OPERATIONAL FLIGHT
  PROGRAM (OFP), slide-17 title 'allowable behavior', slide-20 spacing,
  slide-25 duplicate-box removal, slide-5 progressive 3-step build animation.
- New slide 4 'Running example: Sleep Advisor' inserted after the Section-1
  opener: R1-R7 at requirements level, a phone mockup with the Sleep Advisor
  app icon, and the 'They do not yet say enough to build it.' band. Gives
  students a system they understand before the first exercise.

Adds the Sleep Advisor app-icon assets (slides/assets/sleep-advisor-icon.{svg,png})
— a night-tile icon: crescent moon + sleep-rhythm waveform with one flagged
departure (the R3/R4 concept).

Co-Authored-By: Claude Opus 4.8 <noreply@anthropic.com>
</commit_message>
<xml_diff>
--- a/course/lectures/act-1-foundations/05-specification/slides/1-5-Specification.pptx
+++ b/course/lectures/act-1-foundations/05-specification/slides/1-5-Specification.pptx
@@ -11,6 +11,7 @@
     <p:sldId id="517" r:id="rId2"/>
     <p:sldId id="738" r:id="rId3"/>
     <p:sldId id="651" r:id="rId4"/>
+    <p:sldId id="758" r:id="rId36"/>
     <p:sldId id="744" r:id="rId5"/>
     <p:sldId id="729" r:id="rId6"/>
     <p:sldId id="745" r:id="rId7"/>
@@ -1641,7 +1642,7 @@
           <a:p>
             <a:r>
               <a:rPr lang="en-US" dirty="0"/>
-              <a:t>None of them is a tier or a refinement of another. They are peers. They join through shared concepts: an observation, a night, an advisory. That shared vocabulary is what lets the four views describe one system without any of them being complete.</a:t>
+              <a:t>None of them is a tier or a refinement of another. They are peers. They join through shared concepts: an observation, a night, an advisory. That shared vocabulary is what lets the three views describe one system without any of them being complete.</a:t>
             </a:r>
           </a:p>
           <a:p>
@@ -1816,7 +1817,7 @@
           <a:p>
             <a:r>
               <a:rPr lang="en-US" dirty="0"/>
-              <a:t>Two things to notice. First, the obligations bound a region; they do not select a point. The realizations inside that intersection can differ substantially and all remain acceptable. Part II calls those remaining choices degrees of freedom, and a tolerance is what bounds the permitted variation.</a:t>
+              <a:t>Two things to notice. First, the obligations bound a region; they do not select a point. The realizations inside that intersection can differ substantially and all remain acceptable. MAGE Part II calls those remaining choices degrees of freedom, and a tolerance is what bounds the permitted variation.</a:t>
             </a:r>
           </a:p>
           <a:p>
@@ -1899,7 +1900,7 @@
           <a:p>
             <a:r>
               <a:rPr lang="en-US" dirty="0"/>
-              <a:t>Part II's diagnostic is the useful one to give students. If a proposed realization would provoke not that, then some consequential boundary remains, whether or not anyone has written it down. The choice was never wholly free.</a:t>
+              <a:t>MAGE Part II's diagnostic is the useful one to give students. If a proposed realization would provoke not that, then some consequential boundary remains, whether or not anyone has written it down. The choice was never wholly free.</a:t>
             </a:r>
           </a:p>
           <a:p>
@@ -1985,7 +1986,7 @@
           <a:p>
             <a:r>
               <a:rPr lang="en-US" sz="1200" dirty="0"/>
-              <a:t>- Load time: free if it is comfort, tacit or an obligation if someone decides while waiting.</a:t>
+              <a:t>- Load time: free if it is comfort, tacit or an obligation if the delay causes users to abandon the operation, retry, or otherwise changes their experience.</a:t>
             </a:r>
           </a:p>
           <a:p>
@@ -2030,7 +2031,7 @@
           <a:p>
             <a:r>
               <a:rPr lang="en-US" sz="1200" dirty="0"/>
-              <a:t>One minute alone, then two with a neighbour. Argue for a classification, then say what the system would have to be for you to change your mind.</a:t>
+              <a:t>One minute alone, then two with a neighbour. Argue for a classification, then say what additional context would change your classification.</a:t>
             </a:r>
           </a:p>
           <a:p>
@@ -2503,7 +2504,7 @@
           <a:p>
             <a:r>
               <a:rPr lang="en-US" sz="1200" dirty="0"/>
-              <a:t>Read the boxed rule aloud as one sentence and stop. If students remember one artifact from this lecture, it should be this box and the degrees-of-freedom figure.</a:t>
+              <a:t>Read the three rules slowly and stop. They are the practical synthesis of the lecture. If students remember one artifact from this lecture, it should be this box and the degrees-of-freedom figure.</a:t>
             </a:r>
           </a:p>
           <a:p>
@@ -2765,11 +2766,58 @@
           <a:p>
             <a:r>
               <a:rPr lang="en-US" sz="1200" dirty="0"/>
-              <a:t>Section one. We have the model. Now the first question: what does specification actually add to a requirement?</a:t>
+              <a:t>Section one. The opening slide gave us a model of moving from requirements to acceptable realizations. Now we ask the first question: what does specification add?</a:t>
             </a:r>
           </a:p>
           <a:p>
             <a:endParaRPr lang="en-US" sz="1200"/>
+          </a:p>
+        </p:txBody>
+      </p:sp>
+    </p:spTree>
+  </p:cSld>
+  <p:clrMapOvr>
+    <a:masterClrMapping/>
+  </p:clrMapOvr>
+</p:notes>
+</file>
+
+<file path=ppt/notesSlides/notesSlide30.xml><?xml version="1.0" encoding="utf-8"?>
+<p:notes xmlns:a="http://schemas.openxmlformats.org/drawingml/2006/main" xmlns:r="http://schemas.openxmlformats.org/officeDocument/2006/relationships" xmlns:p="http://schemas.openxmlformats.org/presentationml/2006/main">
+  <p:cSld>
+    <p:spTree>
+      <p:nvGrpSpPr>
+        <p:cNvPr id="1" name=""/>
+        <p:cNvGrpSpPr/>
+        <p:nvPr/>
+      </p:nvGrpSpPr>
+      <p:grpSpPr>
+        <a:xfrm>
+          <a:off x="0" y="0"/>
+          <a:ext cx="0" cy="0"/>
+          <a:chOff x="0" y="0"/>
+          <a:chExt cx="0" cy="0"/>
+        </a:xfrm>
+      </p:grpSpPr>
+      <p:sp>
+        <p:nvSpPr>
+          <p:cNvPr id="2" name="Notes Placeholder 1"/>
+          <p:cNvSpPr>
+            <a:spLocks noGrp="1"/>
+          </p:cNvSpPr>
+          <p:nvPr>
+            <p:ph type="body" idx="1"/>
+          </p:nvPr>
+        </p:nvSpPr>
+        <p:spPr/>
+        <p:txBody>
+          <a:bodyPr/>
+          <a:lstStyle/>
+          <a:p>
+            <a:r>
+              <a:rPr lang="en-US" sz="1200" dirty="0"/>
+              <a:t>This system is fictional. We will use it throughout the lecture because it is complicated enough to have real specification questions, but small enough that we can keep the whole problem in our heads. These are its requirements. Notice that they sound perfectly reasonable. The question for today is whether they are enough.</a:t>
+            </a:r>
           </a:p>
         </p:txBody>
       </p:sp>
@@ -2856,6 +2904,12 @@
           </a:p>
           <a:p>
             <a:endParaRPr lang="en-US" sz="1200"/>
+          </a:p>
+          <a:p>
+            <a:r>
+              <a:rPr lang="en-US" sz="1200" dirty="0"/>
+              <a:t>We will use this Sleep Advisor app as a running example throughout the lecture.</a:t>
+            </a:r>
           </a:p>
           <a:p>
             <a:r>
@@ -8809,7 +8863,7 @@
                   <a:srgbClr val="8E6F3E"/>
                 </a:solidFill>
               </a:rPr>
-              <a:t>FULL OFP</a:t>
+              <a:t>FULL OPERATIONAL FLIGHT PROGRAM (OFP)</a:t>
             </a:r>
           </a:p>
         </p:txBody>
@@ -11833,7 +11887,7 @@
             </a:pPr>
             <a:r>
               <a:rPr lang="en-US" b="1" dirty="0"/>
-              <a:t>State models expose legal behavior</a:t>
+              <a:t>State models expose allowable behavior</a:t>
             </a:r>
           </a:p>
         </p:txBody>
@@ -14202,7 +14256,22 @@
                   <a:srgbClr val="FFFFFF"/>
                 </a:solidFill>
               </a:rPr>
-              <a:t>consequential obligations, made explicit</a:t>
+              <a:t>consequential obligations</a:t>
+            </a:r>
+            <a:br>
+              <a:rPr lang="en-US" sz="2000" b="0" i="0" dirty="0">
+                <a:solidFill>
+                  <a:srgbClr val="FFFFFF"/>
+                </a:solidFill>
+              </a:rPr>
+            </a:br>
+            <a:r>
+              <a:rPr lang="en-US" sz="2000" b="0" i="0" dirty="0">
+                <a:solidFill>
+                  <a:srgbClr val="FFFFFF"/>
+                </a:solidFill>
+              </a:rPr>
+              <a:t>made explicit</a:t>
             </a:r>
           </a:p>
         </p:txBody>
@@ -15760,7 +15829,7 @@
         </p:nvSpPr>
         <p:spPr>
           <a:xfrm>
-            <a:off x="635000" y="800100"/>
+            <a:off x="635000" y="914400"/>
             <a:ext cx="3048000" cy="279400"/>
           </a:xfrm>
           <a:prstGeom prst="rect">
@@ -15813,7 +15882,7 @@
         </p:blipFill>
         <p:spPr>
           <a:xfrm>
-            <a:off x="279400" y="800100"/>
+            <a:off x="279400" y="914400"/>
             <a:ext cx="279400" cy="279400"/>
           </a:xfrm>
           <a:prstGeom prst="rect">
@@ -20099,45 +20168,6 @@
           </a:p>
         </p:txBody>
       </p:sp>
-      <p:sp>
-        <p:nvSpPr>
-          <p:cNvPr id="71" name="T71"/>
-          <p:cNvSpPr txBox="1"/>
-          <p:nvPr/>
-        </p:nvSpPr>
-        <p:spPr>
-          <a:xfrm>
-            <a:off x="279400" y="5080000"/>
-            <a:ext cx="8559800" cy="1143000"/>
-          </a:xfrm>
-          <a:prstGeom prst="rect">
-            <a:avLst/>
-          </a:prstGeom>
-          <a:noFill/>
-          <a:ln>
-            <a:noFill/>
-          </a:ln>
-        </p:spPr>
-        <p:txBody>
-          <a:bodyPr wrap="square" lIns="0" tIns="0" rIns="0" bIns="0" anchor="t">
-            <a:normAutofit/>
-          </a:bodyPr>
-          <a:lstStyle/>
-          <a:p>
-            <a:pPr algn="ctr">
-              <a:buNone/>
-            </a:pPr>
-            <a:r>
-              <a:rPr lang="en-US" sz="2400" b="1" i="0" dirty="0">
-                <a:solidFill>
-                  <a:srgbClr val="000000"/>
-                </a:solidFill>
-              </a:rPr>
-              <a:t>The boundary was in your head, never in the artifact.</a:t>
-            </a:r>
-          </a:p>
-        </p:txBody>
-      </p:sp>
     </p:spTree>
     <p:extLst>
       <p:ext uri="{BB962C8B-B14F-4D97-AF65-F5344CB8AC3E}">
@@ -23138,6 +23168,758 @@
 </p:sld>
 </file>
 
+<file path=ppt/slides/slide30.xml><?xml version="1.0" encoding="utf-8"?>
+<p:sld xmlns:a="http://schemas.openxmlformats.org/drawingml/2006/main" xmlns:r="http://schemas.openxmlformats.org/officeDocument/2006/relationships" xmlns:p="http://schemas.openxmlformats.org/presentationml/2006/main">
+  <p:cSld>
+    <p:spTree>
+      <p:nvGrpSpPr>
+        <p:cNvPr id="1" name=""/>
+        <p:cNvGrpSpPr/>
+        <p:nvPr/>
+      </p:nvGrpSpPr>
+      <p:grpSpPr>
+        <a:xfrm>
+          <a:off x="0" y="0"/>
+          <a:ext cx="0" cy="0"/>
+          <a:chOff x="0" y="0"/>
+          <a:chExt cx="0" cy="0"/>
+        </a:xfrm>
+      </p:grpSpPr>
+      <p:sp>
+        <p:nvSpPr>
+          <p:cNvPr id="3" name="Title 2"/>
+          <p:cNvSpPr>
+            <a:spLocks noGrp="1"/>
+          </p:cNvSpPr>
+          <p:nvPr>
+            <p:ph type="title"/>
+          </p:nvPr>
+        </p:nvSpPr>
+        <p:spPr/>
+        <p:txBody>
+          <a:bodyPr>
+            <a:normAutofit/>
+          </a:bodyPr>
+          <a:lstStyle/>
+          <a:p>
+            <a:pPr algn="l">
+              <a:buNone/>
+            </a:pPr>
+            <a:r>
+              <a:rPr lang="en-US" sz="3000" b="1" i="0" dirty="0">
+                <a:solidFill>
+                  <a:srgbClr val="000000"/>
+                </a:solidFill>
+              </a:rPr>
+              <a:t>Running example: Sleep Advisor</a:t>
+            </a:r>
+          </a:p>
+        </p:txBody>
+      </p:sp>
+      <p:sp>
+        <p:nvSpPr>
+          <p:cNvPr id="4" name="Slide Number Placeholder 3"/>
+          <p:cNvSpPr>
+            <a:spLocks noGrp="1"/>
+          </p:cNvSpPr>
+          <p:nvPr>
+            <p:ph type="sldNum" sz="quarter" idx="4"/>
+          </p:nvPr>
+        </p:nvSpPr>
+        <p:spPr/>
+        <p:txBody>
+          <a:bodyPr/>
+          <a:lstStyle/>
+          <a:p>
+            <a:fld id="{1A2B3C4D-5E6F-7A8B-9C0D-1E2F3A4B5C6D}" type="slidenum">
+              <a:rPr lang="en-US" smtClean="0"/>
+              <a:t>4</a:t>
+            </a:fld>
+            <a:endParaRPr lang="en-US"/>
+          </a:p>
+        </p:txBody>
+      </p:sp>
+      <p:sp>
+        <p:nvSpPr>
+          <p:cNvPr id="100" name="Phone"/>
+          <p:cNvSpPr/>
+          <p:nvPr/>
+        </p:nvSpPr>
+        <p:spPr>
+          <a:xfrm>
+            <a:off x="558800" y="1229360"/>
+            <a:ext cx="2209800" cy="3200400"/>
+          </a:xfrm>
+          <a:prstGeom prst="roundRect">
+            <a:avLst>
+              <a:gd name="adj" fmla="val 8000"/>
+            </a:avLst>
+          </a:prstGeom>
+          <a:solidFill>
+            <a:srgbClr val="FFFFFF"/>
+          </a:solidFill>
+          <a:ln w="28575">
+            <a:solidFill>
+              <a:srgbClr val="8E6F3E"/>
+            </a:solidFill>
+          </a:ln>
+        </p:spPr>
+        <p:txBody>
+          <a:bodyPr wrap="square" lIns="109728" tIns="82296" rIns="109728" bIns="82296" anchor="t">
+            <a:normAutofit/>
+          </a:bodyPr>
+          <a:lstStyle/>
+          <a:p>
+            <a:endParaRPr/>
+          </a:p>
+        </p:txBody>
+      </p:sp>
+      <p:sp>
+        <p:nvSpPr>
+          <p:cNvPr id="101" name="HomeBar"/>
+          <p:cNvSpPr/>
+          <p:nvPr/>
+        </p:nvSpPr>
+        <p:spPr>
+          <a:xfrm>
+            <a:off x="1320800" y="4172585"/>
+            <a:ext cx="685800" cy="57150"/>
+          </a:xfrm>
+          <a:prstGeom prst="roundRect">
+            <a:avLst>
+              <a:gd name="adj" fmla="val 50000"/>
+            </a:avLst>
+          </a:prstGeom>
+          <a:solidFill>
+            <a:srgbClr val="C9B991"/>
+          </a:solidFill>
+          <a:ln>
+            <a:noFill/>
+          </a:ln>
+        </p:spPr>
+        <p:txBody>
+          <a:bodyPr/>
+          <a:lstStyle/>
+          <a:p>
+            <a:endParaRPr/>
+          </a:p>
+        </p:txBody>
+      </p:sp>
+      <p:pic>
+        <p:nvPicPr>
+          <p:cNvPr id="102" name="AppIcon" descr="Sleep Advisor app icon: gold crescent moon and sleep waveform on a dark rounded tile"/>
+          <p:cNvPicPr>
+            <a:picLocks noChangeAspect="1"/>
+          </p:cNvPicPr>
+          <p:nvPr/>
+        </p:nvPicPr>
+        <p:blipFill>
+          <a:blip r:embed="rId3"/>
+          <a:stretch>
+            <a:fillRect/>
+          </a:stretch>
+        </p:blipFill>
+        <p:spPr>
+          <a:xfrm>
+            <a:off x="1054100" y="1629410"/>
+            <a:ext cx="1219200" cy="1219200"/>
+          </a:xfrm>
+          <a:prstGeom prst="rect">
+            <a:avLst/>
+          </a:prstGeom>
+        </p:spPr>
+      </p:pic>
+      <p:sp>
+        <p:nvSpPr>
+          <p:cNvPr id="105" name="ScreenBar1"/>
+          <p:cNvSpPr/>
+          <p:nvPr/>
+        </p:nvSpPr>
+        <p:spPr>
+          <a:xfrm>
+            <a:off x="711200" y="3397250"/>
+            <a:ext cx="1905000" cy="114300"/>
+          </a:xfrm>
+          <a:prstGeom prst="roundRect">
+            <a:avLst>
+              <a:gd name="adj" fmla="val 50000"/>
+            </a:avLst>
+          </a:prstGeom>
+          <a:solidFill>
+            <a:srgbClr val="F5F1E8"/>
+          </a:solidFill>
+          <a:ln w="9525">
+            <a:solidFill>
+              <a:srgbClr val="C9B991"/>
+            </a:solidFill>
+          </a:ln>
+        </p:spPr>
+        <p:txBody>
+          <a:bodyPr/>
+          <a:lstStyle/>
+          <a:p>
+            <a:endParaRPr/>
+          </a:p>
+        </p:txBody>
+      </p:sp>
+      <p:sp>
+        <p:nvSpPr>
+          <p:cNvPr id="106" name="ScreenBar2"/>
+          <p:cNvSpPr/>
+          <p:nvPr/>
+        </p:nvSpPr>
+        <p:spPr>
+          <a:xfrm>
+            <a:off x="711200" y="3648710"/>
+            <a:ext cx="1524000" cy="114300"/>
+          </a:xfrm>
+          <a:prstGeom prst="roundRect">
+            <a:avLst>
+              <a:gd name="adj" fmla="val 50000"/>
+            </a:avLst>
+          </a:prstGeom>
+          <a:solidFill>
+            <a:srgbClr val="F5F1E8"/>
+          </a:solidFill>
+          <a:ln w="9525">
+            <a:solidFill>
+              <a:srgbClr val="C9B991"/>
+            </a:solidFill>
+          </a:ln>
+        </p:spPr>
+        <p:txBody>
+          <a:bodyPr/>
+          <a:lstStyle/>
+          <a:p>
+            <a:endParaRPr/>
+          </a:p>
+        </p:txBody>
+      </p:sp>
+      <p:sp>
+        <p:nvSpPr>
+          <p:cNvPr id="107" name="ScreenBar3"/>
+          <p:cNvSpPr/>
+          <p:nvPr/>
+        </p:nvSpPr>
+        <p:spPr>
+          <a:xfrm>
+            <a:off x="711200" y="3900170"/>
+            <a:ext cx="1714500" cy="114300"/>
+          </a:xfrm>
+          <a:prstGeom prst="roundRect">
+            <a:avLst>
+              <a:gd name="adj" fmla="val 50000"/>
+            </a:avLst>
+          </a:prstGeom>
+          <a:solidFill>
+            <a:srgbClr val="F5F1E8"/>
+          </a:solidFill>
+          <a:ln w="9525">
+            <a:solidFill>
+              <a:srgbClr val="C9B991"/>
+            </a:solidFill>
+          </a:ln>
+        </p:spPr>
+        <p:txBody>
+          <a:bodyPr/>
+          <a:lstStyle/>
+          <a:p>
+            <a:endParaRPr/>
+          </a:p>
+        </p:txBody>
+      </p:sp>
+      <p:sp>
+        <p:nvSpPr>
+          <p:cNvPr id="103" name="Wordmark"/>
+          <p:cNvSpPr txBox="1"/>
+          <p:nvPr/>
+        </p:nvSpPr>
+        <p:spPr>
+          <a:xfrm>
+            <a:off x="609600" y="2940050"/>
+            <a:ext cx="2108200" cy="274320"/>
+          </a:xfrm>
+          <a:prstGeom prst="rect">
+            <a:avLst/>
+          </a:prstGeom>
+          <a:noFill/>
+          <a:ln>
+            <a:noFill/>
+          </a:ln>
+        </p:spPr>
+        <p:txBody>
+          <a:bodyPr lIns="0" tIns="0" rIns="0" bIns="0" anchor="ctr">
+            <a:noAutofit/>
+          </a:bodyPr>
+          <a:lstStyle/>
+          <a:p>
+            <a:pPr algn="ctr">
+              <a:buNone/>
+            </a:pPr>
+            <a:r>
+              <a:rPr lang="en-US" sz="1400" b="1" spc="120" dirty="0">
+                <a:solidFill>
+                  <a:srgbClr val="8E6F3E"/>
+                </a:solidFill>
+              </a:rPr>
+              <a:t>SLEEP ADVISOR</a:t>
+            </a:r>
+          </a:p>
+        </p:txBody>
+      </p:sp>
+      <p:sp>
+        <p:nvSpPr>
+          <p:cNvPr id="104" name="AppDesc"/>
+          <p:cNvSpPr txBox="1"/>
+          <p:nvPr/>
+        </p:nvSpPr>
+        <p:spPr>
+          <a:xfrm>
+            <a:off x="279400" y="4632960"/>
+            <a:ext cx="2781300" cy="731520"/>
+          </a:xfrm>
+          <a:prstGeom prst="rect">
+            <a:avLst/>
+          </a:prstGeom>
+          <a:noFill/>
+          <a:ln>
+            <a:noFill/>
+          </a:ln>
+        </p:spPr>
+        <p:txBody>
+          <a:bodyPr lIns="0" tIns="0" rIns="0" bIns="0" anchor="t">
+            <a:noAutofit/>
+          </a:bodyPr>
+          <a:lstStyle/>
+          <a:p>
+            <a:pPr algn="l">
+              <a:buNone/>
+            </a:pPr>
+            <a:r>
+              <a:rPr lang="en-US" sz="1300" b="0" i="0" dirty="0">
+                <a:solidFill>
+                  <a:srgbClr val="000000"/>
+                </a:solidFill>
+              </a:rPr>
+              <a:t>A hypothetical app that learns a user's normal sleep patterns and helps them notice potentially important changes.</a:t>
+            </a:r>
+          </a:p>
+        </p:txBody>
+      </p:sp>
+      <p:sp>
+        <p:nvSpPr>
+          <p:cNvPr id="110" name="ReqR1"/>
+          <p:cNvSpPr/>
+          <p:nvPr/>
+        </p:nvSpPr>
+        <p:spPr>
+          <a:xfrm>
+            <a:off x="3175000" y="939800"/>
+            <a:ext cx="5664200" cy="616857"/>
+          </a:xfrm>
+          <a:prstGeom prst="rect">
+            <a:avLst/>
+          </a:prstGeom>
+          <a:solidFill>
+            <a:srgbClr val="F5F1E8"/>
+          </a:solidFill>
+          <a:ln w="12700">
+            <a:solidFill>
+              <a:srgbClr val="C9B991"/>
+            </a:solidFill>
+          </a:ln>
+        </p:spPr>
+        <p:txBody>
+          <a:bodyPr wrap="square" lIns="109728" tIns="82296" rIns="109728" bIns="82296" anchor="ctr">
+            <a:normAutofit/>
+          </a:bodyPr>
+          <a:lstStyle/>
+          <a:p>
+            <a:pPr algn="l">
+              <a:buNone/>
+            </a:pPr>
+            <a:r>
+              <a:rPr lang="en-US" sz="1500" b="1" i="0" dirty="0">
+                <a:solidFill>
+                  <a:srgbClr val="8E6F3E"/>
+                </a:solidFill>
+              </a:rPr>
+              <a:t>R1</a:t>
+            </a:r>
+            <a:r>
+              <a:rPr lang="en-US" sz="1500" b="0" i="0" dirty="0">
+                <a:solidFill>
+                  <a:srgbClr val="000000"/>
+                </a:solidFill>
+              </a:rPr>
+              <a:t>  Track the user's sleep each night.</a:t>
+            </a:r>
+          </a:p>
+        </p:txBody>
+      </p:sp>
+      <p:sp>
+        <p:nvSpPr>
+          <p:cNvPr id="111" name="ReqR2"/>
+          <p:cNvSpPr/>
+          <p:nvPr/>
+        </p:nvSpPr>
+        <p:spPr>
+          <a:xfrm>
+            <a:off x="3175000" y="1648097"/>
+            <a:ext cx="5664200" cy="616857"/>
+          </a:xfrm>
+          <a:prstGeom prst="rect">
+            <a:avLst/>
+          </a:prstGeom>
+          <a:solidFill>
+            <a:srgbClr val="F5F1E8"/>
+          </a:solidFill>
+          <a:ln w="12700">
+            <a:solidFill>
+              <a:srgbClr val="C9B991"/>
+            </a:solidFill>
+          </a:ln>
+        </p:spPr>
+        <p:txBody>
+          <a:bodyPr wrap="square" lIns="109728" tIns="82296" rIns="109728" bIns="82296" anchor="ctr">
+            <a:normAutofit/>
+          </a:bodyPr>
+          <a:lstStyle/>
+          <a:p>
+            <a:pPr algn="l">
+              <a:buNone/>
+            </a:pPr>
+            <a:r>
+              <a:rPr lang="en-US" sz="1500" b="1" i="0" dirty="0">
+                <a:solidFill>
+                  <a:srgbClr val="8E6F3E"/>
+                </a:solidFill>
+              </a:rPr>
+              <a:t>R2</a:t>
+            </a:r>
+            <a:r>
+              <a:rPr lang="en-US" sz="1500" b="0" i="0" dirty="0">
+                <a:solidFill>
+                  <a:srgbClr val="000000"/>
+                </a:solidFill>
+              </a:rPr>
+              <a:t>  Learn what constitutes a normal sleep pattern for the user.</a:t>
+            </a:r>
+          </a:p>
+        </p:txBody>
+      </p:sp>
+      <p:sp>
+        <p:nvSpPr>
+          <p:cNvPr id="112" name="ReqR3"/>
+          <p:cNvSpPr/>
+          <p:nvPr/>
+        </p:nvSpPr>
+        <p:spPr>
+          <a:xfrm>
+            <a:off x="3175000" y="2356394"/>
+            <a:ext cx="5664200" cy="616857"/>
+          </a:xfrm>
+          <a:prstGeom prst="rect">
+            <a:avLst/>
+          </a:prstGeom>
+          <a:solidFill>
+            <a:srgbClr val="F5F1E8"/>
+          </a:solidFill>
+          <a:ln w="12700">
+            <a:solidFill>
+              <a:srgbClr val="C9B991"/>
+            </a:solidFill>
+          </a:ln>
+        </p:spPr>
+        <p:txBody>
+          <a:bodyPr wrap="square" lIns="109728" tIns="82296" rIns="109728" bIns="82296" anchor="ctr">
+            <a:normAutofit/>
+          </a:bodyPr>
+          <a:lstStyle/>
+          <a:p>
+            <a:pPr algn="l">
+              <a:buNone/>
+            </a:pPr>
+            <a:r>
+              <a:rPr lang="en-US" sz="1500" b="1" i="0" dirty="0">
+                <a:solidFill>
+                  <a:srgbClr val="8E6F3E"/>
+                </a:solidFill>
+              </a:rPr>
+              <a:t>R3</a:t>
+            </a:r>
+            <a:r>
+              <a:rPr lang="en-US" sz="1500" b="0" i="0" dirty="0">
+                <a:solidFill>
+                  <a:srgbClr val="000000"/>
+                </a:solidFill>
+              </a:rPr>
+              <a:t>  Identify meaningful departures from the user's normal pattern.</a:t>
+            </a:r>
+          </a:p>
+        </p:txBody>
+      </p:sp>
+      <p:sp>
+        <p:nvSpPr>
+          <p:cNvPr id="113" name="ReqR4"/>
+          <p:cNvSpPr/>
+          <p:nvPr/>
+        </p:nvSpPr>
+        <p:spPr>
+          <a:xfrm>
+            <a:off x="3175000" y="3064691"/>
+            <a:ext cx="5664200" cy="616857"/>
+          </a:xfrm>
+          <a:prstGeom prst="rect">
+            <a:avLst/>
+          </a:prstGeom>
+          <a:solidFill>
+            <a:srgbClr val="F5F1E8"/>
+          </a:solidFill>
+          <a:ln w="12700">
+            <a:solidFill>
+              <a:srgbClr val="C9B991"/>
+            </a:solidFill>
+          </a:ln>
+        </p:spPr>
+        <p:txBody>
+          <a:bodyPr wrap="square" lIns="109728" tIns="82296" rIns="109728" bIns="82296" anchor="ctr">
+            <a:normAutofit/>
+          </a:bodyPr>
+          <a:lstStyle/>
+          <a:p>
+            <a:pPr algn="l">
+              <a:buNone/>
+            </a:pPr>
+            <a:r>
+              <a:rPr lang="en-US" sz="1500" b="1" i="0" dirty="0">
+                <a:solidFill>
+                  <a:srgbClr val="8E6F3E"/>
+                </a:solidFill>
+              </a:rPr>
+              <a:t>R4</a:t>
+            </a:r>
+            <a:r>
+              <a:rPr lang="en-US" sz="1500" b="0" i="0" dirty="0">
+                <a:solidFill>
+                  <a:srgbClr val="000000"/>
+                </a:solidFill>
+              </a:rPr>
+              <a:t>  Alert the user when their sleep pattern suggests illness.</a:t>
+            </a:r>
+          </a:p>
+        </p:txBody>
+      </p:sp>
+      <p:sp>
+        <p:nvSpPr>
+          <p:cNvPr id="114" name="ReqR5"/>
+          <p:cNvSpPr/>
+          <p:nvPr/>
+        </p:nvSpPr>
+        <p:spPr>
+          <a:xfrm>
+            <a:off x="3175000" y="3772988"/>
+            <a:ext cx="5664200" cy="616857"/>
+          </a:xfrm>
+          <a:prstGeom prst="rect">
+            <a:avLst/>
+          </a:prstGeom>
+          <a:solidFill>
+            <a:srgbClr val="F5F1E8"/>
+          </a:solidFill>
+          <a:ln w="12700">
+            <a:solidFill>
+              <a:srgbClr val="C9B991"/>
+            </a:solidFill>
+          </a:ln>
+        </p:spPr>
+        <p:txBody>
+          <a:bodyPr wrap="square" lIns="109728" tIns="82296" rIns="109728" bIns="82296" anchor="ctr">
+            <a:normAutofit/>
+          </a:bodyPr>
+          <a:lstStyle/>
+          <a:p>
+            <a:pPr algn="l">
+              <a:buNone/>
+            </a:pPr>
+            <a:r>
+              <a:rPr lang="en-US" sz="1500" b="1" i="0" dirty="0">
+                <a:solidFill>
+                  <a:srgbClr val="8E6F3E"/>
+                </a:solidFill>
+              </a:rPr>
+              <a:t>R5</a:t>
+            </a:r>
+            <a:r>
+              <a:rPr lang="en-US" sz="1500" b="0" i="0" dirty="0">
+                <a:solidFill>
+                  <a:srgbClr val="000000"/>
+                </a:solidFill>
+              </a:rPr>
+              <a:t>  Adapt when the user's normal sleep pattern changes.</a:t>
+            </a:r>
+          </a:p>
+        </p:txBody>
+      </p:sp>
+      <p:sp>
+        <p:nvSpPr>
+          <p:cNvPr id="115" name="ReqR6"/>
+          <p:cNvSpPr/>
+          <p:nvPr/>
+        </p:nvSpPr>
+        <p:spPr>
+          <a:xfrm>
+            <a:off x="3175000" y="4481285"/>
+            <a:ext cx="5664200" cy="616857"/>
+          </a:xfrm>
+          <a:prstGeom prst="rect">
+            <a:avLst/>
+          </a:prstGeom>
+          <a:solidFill>
+            <a:srgbClr val="F5F1E8"/>
+          </a:solidFill>
+          <a:ln w="12700">
+            <a:solidFill>
+              <a:srgbClr val="C9B991"/>
+            </a:solidFill>
+          </a:ln>
+        </p:spPr>
+        <p:txBody>
+          <a:bodyPr wrap="square" lIns="109728" tIns="82296" rIns="109728" bIns="82296" anchor="ctr">
+            <a:normAutofit/>
+          </a:bodyPr>
+          <a:lstStyle/>
+          <a:p>
+            <a:pPr algn="l">
+              <a:buNone/>
+            </a:pPr>
+            <a:r>
+              <a:rPr lang="en-US" sz="1500" b="1" i="0" dirty="0">
+                <a:solidFill>
+                  <a:srgbClr val="8E6F3E"/>
+                </a:solidFill>
+              </a:rPr>
+              <a:t>R6</a:t>
+            </a:r>
+            <a:r>
+              <a:rPr lang="en-US" sz="1500" b="0" i="0" dirty="0">
+                <a:solidFill>
+                  <a:srgbClr val="000000"/>
+                </a:solidFill>
+              </a:rPr>
+              <a:t>  Provide the user with a weekly summary of their sleep.</a:t>
+            </a:r>
+          </a:p>
+        </p:txBody>
+      </p:sp>
+      <p:sp>
+        <p:nvSpPr>
+          <p:cNvPr id="116" name="ReqR7"/>
+          <p:cNvSpPr/>
+          <p:nvPr/>
+        </p:nvSpPr>
+        <p:spPr>
+          <a:xfrm>
+            <a:off x="3175000" y="5189582"/>
+            <a:ext cx="5664200" cy="616857"/>
+          </a:xfrm>
+          <a:prstGeom prst="rect">
+            <a:avLst/>
+          </a:prstGeom>
+          <a:solidFill>
+            <a:srgbClr val="F5F1E8"/>
+          </a:solidFill>
+          <a:ln w="12700">
+            <a:solidFill>
+              <a:srgbClr val="C9B991"/>
+            </a:solidFill>
+          </a:ln>
+        </p:spPr>
+        <p:txBody>
+          <a:bodyPr wrap="square" lIns="109728" tIns="82296" rIns="109728" bIns="82296" anchor="ctr">
+            <a:normAutofit/>
+          </a:bodyPr>
+          <a:lstStyle/>
+          <a:p>
+            <a:pPr algn="l">
+              <a:buNone/>
+            </a:pPr>
+            <a:r>
+              <a:rPr lang="en-US" sz="1500" b="1" i="0" dirty="0">
+                <a:solidFill>
+                  <a:srgbClr val="8E6F3E"/>
+                </a:solidFill>
+              </a:rPr>
+              <a:t>R7</a:t>
+            </a:r>
+            <a:r>
+              <a:rPr lang="en-US" sz="1500" b="0" i="0" dirty="0">
+                <a:solidFill>
+                  <a:srgbClr val="000000"/>
+                </a:solidFill>
+              </a:rPr>
+              <a:t>  Let the user share a weekly sleep summary with their doctor.</a:t>
+            </a:r>
+          </a:p>
+        </p:txBody>
+      </p:sp>
+      <p:sp>
+        <p:nvSpPr>
+          <p:cNvPr id="120" name="Band"/>
+          <p:cNvSpPr/>
+          <p:nvPr/>
+        </p:nvSpPr>
+        <p:spPr>
+          <a:xfrm>
+            <a:off x="279400" y="5943600"/>
+            <a:ext cx="8559800" cy="502920"/>
+          </a:xfrm>
+          <a:prstGeom prst="rect">
+            <a:avLst/>
+          </a:prstGeom>
+          <a:solidFill>
+            <a:srgbClr val="8E6F3E"/>
+          </a:solidFill>
+          <a:ln>
+            <a:noFill/>
+          </a:ln>
+        </p:spPr>
+        <p:txBody>
+          <a:bodyPr wrap="square" lIns="109728" tIns="82296" rIns="109728" bIns="82296" anchor="ctr">
+            <a:normAutofit/>
+          </a:bodyPr>
+          <a:lstStyle/>
+          <a:p>
+            <a:pPr algn="ctr">
+              <a:buNone/>
+            </a:pPr>
+            <a:r>
+              <a:rPr lang="en-US" sz="2000" b="0" i="0" dirty="0">
+                <a:solidFill>
+                  <a:srgbClr val="FFFFFF"/>
+                </a:solidFill>
+              </a:rPr>
+              <a:t>These say what we want. </a:t>
+            </a:r>
+            <a:r>
+              <a:rPr lang="en-US" sz="2000" b="1" i="0" dirty="0">
+                <a:solidFill>
+                  <a:srgbClr val="FFFFFF"/>
+                </a:solidFill>
+              </a:rPr>
+              <a:t>They do not yet say enough to build it.</a:t>
+            </a:r>
+          </a:p>
+        </p:txBody>
+      </p:sp>
+    </p:spTree>
+  </p:cSld>
+  <p:clrMapOvr>
+    <a:masterClrMapping/>
+  </p:clrMapOvr>
+</p:sld>
+</file>
+
 <file path=ppt/slides/slide4.xml><?xml version="1.0" encoding="utf-8"?>
 <p:sld xmlns:a="http://schemas.openxmlformats.org/drawingml/2006/main" xmlns:r="http://schemas.openxmlformats.org/officeDocument/2006/relationships" xmlns:p="http://schemas.openxmlformats.org/presentationml/2006/main">
   <p:cSld>
@@ -24174,6 +24956,335 @@
   <p:clrMapOvr>
     <a:masterClrMapping/>
   </p:clrMapOvr>
+  <p:timing>
+    <p:tnLst>
+      <p:par>
+        <p:cTn id="1" dur="indefinite" restart="never" nodeType="tmRoot">
+          <p:childTnLst>
+            <p:seq concurrent="1" nextAc="seek">
+              <p:cTn id="2" dur="indefinite" nodeType="mainSeq">
+                <p:childTnLst>
+                  <p:par>
+                    <p:cTn id="3" fill="hold">
+                      <p:stCondLst>
+                        <p:cond delay="indefinite"/>
+                      </p:stCondLst>
+                      <p:childTnLst>
+                        <p:par>
+                          <p:cTn id="4" fill="hold">
+                            <p:stCondLst>
+                              <p:cond delay="0"/>
+                            </p:stCondLst>
+                            <p:childTnLst>
+                              <p:par>
+                                <p:cTn id="5" presetID="10" presetClass="entr" presetSubtype="0" fill="hold" nodeType="clickEffect">
+                                  <p:stCondLst>
+                                    <p:cond delay="0"/>
+                                  </p:stCondLst>
+                                  <p:childTnLst>
+                                    <p:set>
+                                      <p:cBhvr>
+                                        <p:cTn id="6" dur="1" fill="hold">
+                                          <p:stCondLst>
+                                            <p:cond delay="0"/>
+                                          </p:stCondLst>
+                                        </p:cTn>
+                                        <p:tgtEl>
+                                          <p:spTgt spid="60"/>
+                                        </p:tgtEl>
+                                        <p:attrNameLst>
+                                          <p:attrName>style.visibility</p:attrName>
+                                        </p:attrNameLst>
+                                      </p:cBhvr>
+                                      <p:to>
+                                        <p:strVal val="visible"/>
+                                      </p:to>
+                                    </p:set>
+                                    <p:animEffect transition="in" filter="fade">
+                                      <p:cBhvr>
+                                        <p:cTn id="7" dur="400"/>
+                                        <p:tgtEl>
+                                          <p:spTgt spid="60"/>
+                                        </p:tgtEl>
+                                      </p:cBhvr>
+                                    </p:animEffect>
+                                  </p:childTnLst>
+                                </p:cTn>
+                              </p:par>
+                            </p:childTnLst>
+                          </p:cTn>
+                        </p:par>
+                      </p:childTnLst>
+                    </p:cTn>
+                  </p:par>
+                  <p:par>
+                    <p:cTn id="8" fill="hold">
+                      <p:stCondLst>
+                        <p:cond delay="indefinite"/>
+                      </p:stCondLst>
+                      <p:childTnLst>
+                        <p:par>
+                          <p:cTn id="9" fill="hold">
+                            <p:stCondLst>
+                              <p:cond delay="0"/>
+                            </p:stCondLst>
+                            <p:childTnLst>
+                              <p:par>
+                                <p:cTn id="10" presetID="10" presetClass="entr" presetSubtype="0" fill="hold" nodeType="clickEffect">
+                                  <p:stCondLst>
+                                    <p:cond delay="0"/>
+                                  </p:stCondLst>
+                                  <p:childTnLst>
+                                    <p:set>
+                                      <p:cBhvr>
+                                        <p:cTn id="11" dur="1" fill="hold">
+                                          <p:stCondLst>
+                                            <p:cond delay="0"/>
+                                          </p:stCondLst>
+                                        </p:cTn>
+                                        <p:tgtEl>
+                                          <p:spTgt spid="61"/>
+                                        </p:tgtEl>
+                                        <p:attrNameLst>
+                                          <p:attrName>style.visibility</p:attrName>
+                                        </p:attrNameLst>
+                                      </p:cBhvr>
+                                      <p:to>
+                                        <p:strVal val="visible"/>
+                                      </p:to>
+                                    </p:set>
+                                    <p:animEffect transition="in" filter="fade">
+                                      <p:cBhvr>
+                                        <p:cTn id="12" dur="400"/>
+                                        <p:tgtEl>
+                                          <p:spTgt spid="61"/>
+                                        </p:tgtEl>
+                                      </p:cBhvr>
+                                    </p:animEffect>
+                                  </p:childTnLst>
+                                </p:cTn>
+                              </p:par>
+                              <p:par>
+                                <p:cTn id="13" presetID="10" presetClass="entr" presetSubtype="0" fill="hold" nodeType="withEffect">
+                                  <p:stCondLst>
+                                    <p:cond delay="0"/>
+                                  </p:stCondLst>
+                                  <p:childTnLst>
+                                    <p:set>
+                                      <p:cBhvr>
+                                        <p:cTn id="14" dur="1" fill="hold">
+                                          <p:stCondLst>
+                                            <p:cond delay="0"/>
+                                          </p:stCondLst>
+                                        </p:cTn>
+                                        <p:tgtEl>
+                                          <p:spTgt spid="62"/>
+                                        </p:tgtEl>
+                                        <p:attrNameLst>
+                                          <p:attrName>style.visibility</p:attrName>
+                                        </p:attrNameLst>
+                                      </p:cBhvr>
+                                      <p:to>
+                                        <p:strVal val="visible"/>
+                                      </p:to>
+                                    </p:set>
+                                    <p:animEffect transition="in" filter="fade">
+                                      <p:cBhvr>
+                                        <p:cTn id="15" dur="400"/>
+                                        <p:tgtEl>
+                                          <p:spTgt spid="62"/>
+                                        </p:tgtEl>
+                                      </p:cBhvr>
+                                    </p:animEffect>
+                                  </p:childTnLst>
+                                </p:cTn>
+                              </p:par>
+                            </p:childTnLst>
+                          </p:cTn>
+                        </p:par>
+                      </p:childTnLst>
+                    </p:cTn>
+                  </p:par>
+                  <p:par>
+                    <p:cTn id="16" fill="hold">
+                      <p:stCondLst>
+                        <p:cond delay="indefinite"/>
+                      </p:stCondLst>
+                      <p:childTnLst>
+                        <p:par>
+                          <p:cTn id="17" fill="hold">
+                            <p:stCondLst>
+                              <p:cond delay="0"/>
+                            </p:stCondLst>
+                            <p:childTnLst>
+                              <p:par>
+                                <p:cTn id="18" presetID="10" presetClass="entr" presetSubtype="0" fill="hold" nodeType="clickEffect">
+                                  <p:stCondLst>
+                                    <p:cond delay="0"/>
+                                  </p:stCondLst>
+                                  <p:childTnLst>
+                                    <p:set>
+                                      <p:cBhvr>
+                                        <p:cTn id="19" dur="1" fill="hold">
+                                          <p:stCondLst>
+                                            <p:cond delay="0"/>
+                                          </p:stCondLst>
+                                        </p:cTn>
+                                        <p:tgtEl>
+                                          <p:spTgt spid="63"/>
+                                        </p:tgtEl>
+                                        <p:attrNameLst>
+                                          <p:attrName>style.visibility</p:attrName>
+                                        </p:attrNameLst>
+                                      </p:cBhvr>
+                                      <p:to>
+                                        <p:strVal val="visible"/>
+                                      </p:to>
+                                    </p:set>
+                                    <p:animEffect transition="in" filter="fade">
+                                      <p:cBhvr>
+                                        <p:cTn id="20" dur="400"/>
+                                        <p:tgtEl>
+                                          <p:spTgt spid="63"/>
+                                        </p:tgtEl>
+                                      </p:cBhvr>
+                                    </p:animEffect>
+                                  </p:childTnLst>
+                                </p:cTn>
+                              </p:par>
+                              <p:par>
+                                <p:cTn id="21" presetID="10" presetClass="entr" presetSubtype="0" fill="hold" nodeType="withEffect">
+                                  <p:stCondLst>
+                                    <p:cond delay="0"/>
+                                  </p:stCondLst>
+                                  <p:childTnLst>
+                                    <p:set>
+                                      <p:cBhvr>
+                                        <p:cTn id="22" dur="1" fill="hold">
+                                          <p:stCondLst>
+                                            <p:cond delay="0"/>
+                                          </p:stCondLst>
+                                        </p:cTn>
+                                        <p:tgtEl>
+                                          <p:spTgt spid="64"/>
+                                        </p:tgtEl>
+                                        <p:attrNameLst>
+                                          <p:attrName>style.visibility</p:attrName>
+                                        </p:attrNameLst>
+                                      </p:cBhvr>
+                                      <p:to>
+                                        <p:strVal val="visible"/>
+                                      </p:to>
+                                    </p:set>
+                                    <p:animEffect transition="in" filter="fade">
+                                      <p:cBhvr>
+                                        <p:cTn id="23" dur="400"/>
+                                        <p:tgtEl>
+                                          <p:spTgt spid="64"/>
+                                        </p:tgtEl>
+                                      </p:cBhvr>
+                                    </p:animEffect>
+                                  </p:childTnLst>
+                                </p:cTn>
+                              </p:par>
+                              <p:par>
+                                <p:cTn id="24" presetID="10" presetClass="entr" presetSubtype="0" fill="hold" nodeType="withEffect">
+                                  <p:stCondLst>
+                                    <p:cond delay="0"/>
+                                  </p:stCondLst>
+                                  <p:childTnLst>
+                                    <p:set>
+                                      <p:cBhvr>
+                                        <p:cTn id="25" dur="1" fill="hold">
+                                          <p:stCondLst>
+                                            <p:cond delay="0"/>
+                                          </p:stCondLst>
+                                        </p:cTn>
+                                        <p:tgtEl>
+                                          <p:spTgt spid="65"/>
+                                        </p:tgtEl>
+                                        <p:attrNameLst>
+                                          <p:attrName>style.visibility</p:attrName>
+                                        </p:attrNameLst>
+                                      </p:cBhvr>
+                                      <p:to>
+                                        <p:strVal val="visible"/>
+                                      </p:to>
+                                    </p:set>
+                                    <p:animEffect transition="in" filter="fade">
+                                      <p:cBhvr>
+                                        <p:cTn id="26" dur="400"/>
+                                        <p:tgtEl>
+                                          <p:spTgt spid="65"/>
+                                        </p:tgtEl>
+                                      </p:cBhvr>
+                                    </p:animEffect>
+                                  </p:childTnLst>
+                                </p:cTn>
+                              </p:par>
+                              <p:par>
+                                <p:cTn id="27" presetID="10" presetClass="entr" presetSubtype="0" fill="hold" nodeType="withEffect">
+                                  <p:stCondLst>
+                                    <p:cond delay="0"/>
+                                  </p:stCondLst>
+                                  <p:childTnLst>
+                                    <p:set>
+                                      <p:cBhvr>
+                                        <p:cTn id="28" dur="1" fill="hold">
+                                          <p:stCondLst>
+                                            <p:cond delay="0"/>
+                                          </p:stCondLst>
+                                        </p:cTn>
+                                        <p:tgtEl>
+                                          <p:spTgt spid="66"/>
+                                        </p:tgtEl>
+                                        <p:attrNameLst>
+                                          <p:attrName>style.visibility</p:attrName>
+                                        </p:attrNameLst>
+                                      </p:cBhvr>
+                                      <p:to>
+                                        <p:strVal val="visible"/>
+                                      </p:to>
+                                    </p:set>
+                                    <p:animEffect transition="in" filter="fade">
+                                      <p:cBhvr>
+                                        <p:cTn id="29" dur="400"/>
+                                        <p:tgtEl>
+                                          <p:spTgt spid="66"/>
+                                        </p:tgtEl>
+                                      </p:cBhvr>
+                                    </p:animEffect>
+                                  </p:childTnLst>
+                                </p:cTn>
+                              </p:par>
+                            </p:childTnLst>
+                          </p:cTn>
+                        </p:par>
+                      </p:childTnLst>
+                    </p:cTn>
+                  </p:par>
+                </p:childTnLst>
+              </p:cTn>
+              <p:prevCondLst>
+                <p:cond evt="onPrev" delay="0">
+                  <p:tgtEl>
+                    <p:sldTgt/>
+                  </p:tgtEl>
+                </p:cond>
+              </p:prevCondLst>
+              <p:nextCondLst>
+                <p:cond evt="onNext" delay="0">
+                  <p:tgtEl>
+                    <p:sldTgt/>
+                  </p:tgtEl>
+                </p:cond>
+              </p:nextCondLst>
+            </p:seq>
+          </p:childTnLst>
+        </p:cTn>
+      </p:par>
+    </p:tnLst>
+  </p:timing>
 </p:sld>
 </file>
 
@@ -25120,7 +26231,7 @@
                   <a:srgbClr val="000000"/>
                 </a:solidFill>
               </a:rPr>
-              <a:t>What must it do?</a:t>
+              <a:t>What must the app do?</a:t>
             </a:r>
           </a:p>
         </p:txBody>
@@ -25179,7 +26290,7 @@
                   <a:srgbClr val="000000"/>
                 </a:solidFill>
               </a:rPr>
-              <a:t>What is missing?</a:t>
+              <a:t>What facts are missing?</a:t>
             </a:r>
           </a:p>
         </p:txBody>
@@ -25238,7 +26349,7 @@
                   <a:srgbClr val="000000"/>
                 </a:solidFill>
               </a:rPr>
-              <a:t>What can stay open?</a:t>
+              <a:t>What can remain unspecified?</a:t>
             </a:r>
           </a:p>
         </p:txBody>

</xml_diff>

<commit_message>
course(specification): 4 notes copy nits — stop characterizing the Sleep Advisor, drop stray MAGE-Moment narration
- Section opener: 'one small system' -> 'one system' (don't minimize the Sleep Advisor).
- Generalize slide: 'the same thing happens in our much simpler system' -> '…in the Sleep Advisor' (name it, don't characterize it).
- Section-3 divider: delete the 'Leads straight into the first MAGE Moment' instructor sentence (the next slide is not a marked MAGE Moment — provenance narration we removed); the pacing sentence 'Do not pause for discussion here' is retained.
- A-7E intro: 'a real specification at full scale' -> 'a substantial real specification' (plainer).

Co-Authored-By: Claude Opus 4.8 <noreply@anthropic.com>
</commit_message>
<xml_diff>
--- a/course/lectures/act-1-foundations/05-specification/slides/1-5-Specification.pptx
+++ b/course/lectures/act-1-foundations/05-specification/slides/1-5-Specification.pptx
@@ -1011,7 +1011,7 @@
           </a:p>
           <a:p>
             <a:r>
-              <a:t>The A-7E needed several representations because different obligations required us to see different things. The same thing happens in our much simpler system.</a:t>
+              <a:t>The A-7E needed several representations because different obligations required us to see different things. The same thing happens in the Sleep Advisor.</a:t>
             </a:r>
           </a:p>
           <a:p>
@@ -1678,49 +1678,34 @@
           <a:lstStyle/>
           <a:p>
             <a:r>
-              <a:rPr lang="en-US" sz="1200" dirty="0"/>
               <a:t>20 seconds — Mark the turn from how we represent obligations to how many we should impose.</a:t>
             </a:r>
           </a:p>
-          <a:p>
-            <a:endParaRPr lang="en-US" sz="1200"/>
-          </a:p>
-          <a:p>
-            <a:r>
-              <a:rPr lang="en-US" sz="1200" dirty="0"/>
+          <a:p/>
+          <a:p>
+            <a:r>
               <a:t>- Sections 1 and 2 were about making obligations explicit and visible. This section asks how many there should be.</a:t>
             </a:r>
           </a:p>
-          <a:p>
-            <a:endParaRPr lang="en-US" sz="1200"/>
-          </a:p>
-          <a:p>
-            <a:r>
-              <a:rPr lang="en-US" sz="1200" dirty="0"/>
-              <a:t>- Leads straight into the first MAGE Moment. Do not pause for discussion here.</a:t>
-            </a:r>
-          </a:p>
-          <a:p>
-            <a:endParaRPr lang="en-US" sz="1200"/>
-          </a:p>
-          <a:p>
-            <a:r>
-              <a:rPr lang="en-US" sz="1200" dirty="0"/>
+          <a:p/>
+          <a:p>
+            <a:r>
+              <a:t>- Do not pause for discussion here.</a:t>
+            </a:r>
+          </a:p>
+          <a:p/>
+          <a:p>
+            <a:r>
               <a:t>=====</a:t>
             </a:r>
           </a:p>
-          <a:p>
-            <a:endParaRPr lang="en-US" sz="1200"/>
-          </a:p>
-          <a:p>
-            <a:r>
-              <a:rPr lang="en-US" sz="1200" dirty="0"/>
+          <a:p/>
+          <a:p>
+            <a:r>
               <a:t>Section three. We now know how to write obligations down and how to choose a representation that makes them visible. The harder question is how much of the realization we should be deciding at all.</a:t>
             </a:r>
           </a:p>
-          <a:p>
-            <a:endParaRPr lang="en-US" sz="1200"/>
-          </a:p>
+          <a:p/>
         </p:txBody>
       </p:sp>
     </p:spTree>
@@ -2600,7 +2585,7 @@
           <a:p/>
           <a:p>
             <a:r>
-              <a:t>Let's make that question concrete with one small system we'll use throughout the lecture.</a:t>
+              <a:t>Let's make that question concrete with one system we'll use throughout the lecture.</a:t>
             </a:r>
           </a:p>
         </p:txBody>
@@ -3149,7 +3134,7 @@
           <a:lstStyle/>
           <a:p>
             <a:r>
-              <a:t>For the next few minutes, I want to show you a real specification at full scale.</a:t>
+              <a:t>For the next few minutes, I want to show you a substantial real specification.</a:t>
             </a:r>
           </a:p>
           <a:p>

</xml_diff>

<commit_message>
course(specification): fix deck corruption — remove orphaned slide animation (dangling spid target)
The tacit-requirements slide's <p:timing> tree still animated shape id 71 (the
duplicate brown box deleted in the earlier duplicate-removal edit). An animation
targeting a non-existent shape is invalid OOXML — PowerPoint flagged the file
and offered to repair. Remove that orphaned <p:timing> block (the shape it
revealed is gone), matching PowerPoint's own repair. Surgical: only that slide's
XML changes; all content, notes, and the slide-6 build animation are preserved.
Validated: no dangling animation targets remain, LibreOffice round-trips clean.

Co-Authored-By: Claude Opus 4.8 <noreply@anthropic.com>
</commit_message>
<xml_diff>
--- a/course/lectures/act-1-foundations/05-specification/slides/1-5-Specification.pptx
+++ b/course/lectures/act-1-foundations/05-specification/slides/1-5-Specification.pptx
@@ -20435,89 +20435,6 @@
   <p:clrMapOvr>
     <a:masterClrMapping/>
   </p:clrMapOvr>
-  <p:timing>
-    <p:tnLst>
-      <p:par>
-        <p:cTn id="1" dur="indefinite" restart="never" nodeType="tmRoot">
-          <p:childTnLst>
-            <p:seq concurrent="1" nextAc="seek">
-              <p:cTn id="2" dur="indefinite" nodeType="mainSeq">
-                <p:childTnLst>
-                  <p:par>
-                    <p:cTn id="3" fill="hold">
-                      <p:stCondLst>
-                        <p:cond delay="indefinite"/>
-                      </p:stCondLst>
-                      <p:childTnLst>
-                        <p:par>
-                          <p:cTn id="4" fill="hold">
-                            <p:stCondLst>
-                              <p:cond delay="0"/>
-                            </p:stCondLst>
-                            <p:childTnLst>
-                              <p:par>
-                                <p:cTn id="5" presetID="10" presetClass="entr" presetSubtype="0" fill="hold" nodeType="clickEffect">
-                                  <p:stCondLst>
-                                    <p:cond delay="0"/>
-                                  </p:stCondLst>
-                                  <p:childTnLst>
-                                    <p:set>
-                                      <p:cBhvr>
-                                        <p:cTn id="6" dur="1" fill="hold">
-                                          <p:stCondLst>
-                                            <p:cond delay="0"/>
-                                          </p:stCondLst>
-                                        </p:cTn>
-                                        <p:tgtEl>
-                                          <p:spTgt spid="71"/>
-                                        </p:tgtEl>
-                                        <p:attrNameLst>
-                                          <p:attrName>style.visibility</p:attrName>
-                                        </p:attrNameLst>
-                                      </p:cBhvr>
-                                      <p:to>
-                                        <p:strVal val="visible"/>
-                                      </p:to>
-                                    </p:set>
-                                    <p:animEffect transition="in" filter="fade">
-                                      <p:cBhvr>
-                                        <p:cTn id="7" dur="400"/>
-                                        <p:tgtEl>
-                                          <p:spTgt spid="71"/>
-                                        </p:tgtEl>
-                                      </p:cBhvr>
-                                    </p:animEffect>
-                                  </p:childTnLst>
-                                </p:cTn>
-                              </p:par>
-                            </p:childTnLst>
-                          </p:cTn>
-                        </p:par>
-                      </p:childTnLst>
-                    </p:cTn>
-                  </p:par>
-                </p:childTnLst>
-              </p:cTn>
-              <p:prevCondLst>
-                <p:cond evt="onPrev" delay="0">
-                  <p:tgtEl>
-                    <p:sldTgt/>
-                  </p:tgtEl>
-                </p:cond>
-              </p:prevCondLst>
-              <p:nextCondLst>
-                <p:cond evt="onNext" delay="0">
-                  <p:tgtEl>
-                    <p:sldTgt/>
-                  </p:tgtEl>
-                </p:cond>
-              </p:nextCondLst>
-            </p:seq>
-          </p:childTnLst>
-        </p:cTn>
-      </p:par>
-    </p:tnLst>
-  </p:timing>
 </p:sld>
 </file>
 

</xml_diff>

<commit_message>
course(specification): update 1-5 deck to latest author revision (v3)
Replace the deck with the author's latest PowerPoint revision. 31 slides;
verified no dangling animation targets (corruption class clean).

Co-Authored-By: Claude Opus 4.8 <noreply@anthropic.com>
</commit_message>
<xml_diff>
--- a/course/lectures/act-1-foundations/05-specification/slides/1-5-Specification.pptx
+++ b/course/lectures/act-1-foundations/05-specification/slides/1-5-Specification.pptx
@@ -5,7 +5,7 @@
     <p:sldMasterId id="2147483708" r:id="rId1"/>
   </p:sldMasterIdLst>
   <p:notesMasterIdLst>
-    <p:notesMasterId r:id="rId34"/>
+    <p:notesMasterId r:id="rId33"/>
   </p:notesMasterIdLst>
   <p:sldIdLst>
     <p:sldId id="517" r:id="rId2"/>
@@ -38,7 +38,7 @@
     <p:sldId id="757" r:id="rId29"/>
     <p:sldId id="739" r:id="rId30"/>
     <p:sldId id="740" r:id="rId31"/>
-    <p:sldId id="741" r:id="rId33"/>
+    <p:sldId id="741" r:id="rId32"/>
   </p:sldIdLst>
   <p:sldSz cx="9144000" cy="6858000" type="screen4x3"/>
   <p:notesSz cx="6858000" cy="9144000"/>
@@ -229,7 +229,7 @@
           </a:lstStyle>
           <a:p>
             <a:fld id="{27E8B4C4-0720-F64E-9EEE-9472CF165DC6}" type="datetimeFigureOut">
-              <a:t>9/9/26</a:t>
+              <a:t>9/10/26</a:t>
             </a:fld>
             <a:endParaRPr lang="en-US"/>
           </a:p>
@@ -624,26 +624,31 @@
           <a:lstStyle/>
           <a:p>
             <a:r>
+              <a:rPr dirty="0"/>
               <a:t>For the next few minutes, I want to show you a substantial real specification.</a:t>
             </a:r>
           </a:p>
           <a:p>
             <a:r>
+              <a:rPr dirty="0"/>
               <a:t>This is Alspaugh's Software Requirements for the A-7E Aircraft, Naval Research Laboratory, 1992. It is a substantial specification for aircraft software. What is useful for us is not the age of the system or the particular aircraft. It is that the authors had to make a complicated set of behavioral obligations precise enough for engineers to build against.</a:t>
             </a:r>
           </a:p>
           <a:p>
             <a:r>
+              <a:rPr dirty="0"/>
               <a:t>As we look at it, do not ask which specification language they chose. They did not choose one. They use prose, defined data, tables, modes, timing constraints, and other forms.</a:t>
             </a:r>
           </a:p>
           <a:p>
             <a:r>
+              <a:rPr dirty="0"/>
               <a:t>Instead ask the question we have been asking throughout this lecture: what did they need to constrain, and what could they safely leave to the implementor?</a:t>
             </a:r>
           </a:p>
           <a:p>
             <a:r>
+              <a:rPr dirty="0"/>
               <a:t>We are going to look at four kinds of information the specification makes explicit. First: they needed to specify complicated behavior without unnecessarily specifying how that behavior was implemented.</a:t>
             </a:r>
           </a:p>
@@ -1882,34 +1887,40 @@
           <a:lstStyle/>
           <a:p>
             <a:r>
+              <a:rPr dirty="0"/>
               <a:t>This is the picture behind everything we have said about freedom.</a:t>
             </a:r>
           </a:p>
           <a:p>
             <a:r>
+              <a:rPr dirty="0"/>
               <a:t>The outer box is the space of programs someone could write. Each obligation we state carves out a region: the realizations that satisfy it. The intersection is the acceptable set.</a:t>
             </a:r>
           </a:p>
           <a:p>
             <a:r>
+              <a:rPr dirty="0"/>
               <a:t>Two things to notice. First, the obligations bound a region; they do not select a point. The realizations inside that intersection can differ substantially and all remain acceptable. Those remaining choices are degrees of freedom, and a tolerance bounds the permitted variation.</a:t>
             </a:r>
           </a:p>
           <a:p>
             <a:r>
+              <a:rPr dirty="0"/>
               <a:t>Second, every obligation we add shrinks the region. That is the cost side. So the question is never how much can we specify. It is which eliminated alternatives actually mattered.</a:t>
             </a:r>
           </a:p>
           <a:p>
             <a:r>
+              <a:rPr dirty="0"/>
               <a:t>Narrowing is valuable only when the eliminated alternatives matter. If two realizations are equally acceptable, a specification that forbids one has spent constraint and bought nothing.</a:t>
             </a:r>
           </a:p>
           <a:p>
-            <a:endParaRPr/>
-          </a:p>
-          <a:p>
-            <a:r>
+            <a:endParaRPr dirty="0"/>
+          </a:p>
+          <a:p>
+            <a:r>
+              <a:rPr dirty="0"/>
               <a:t>But there is a trap in calling everything outside those obligations a degree of freedom. Some choices are open because we forgot something—or because we don't yet know what matters.</a:t>
             </a:r>
           </a:p>
@@ -2042,86 +2053,97 @@
           <a:lstStyle/>
           <a:p>
             <a:r>
+              <a:rPr dirty="0"/>
               <a:t>5 minutes — Force engineering judgment rather than vocabulary recall.</a:t>
             </a:r>
           </a:p>
           <a:p>
-            <a:endParaRPr/>
-          </a:p>
-          <a:p>
-            <a:r>
+            <a:endParaRPr dirty="0"/>
+          </a:p>
+          <a:p>
+            <a:r>
+              <a:rPr dirty="0"/>
               <a:t>- Hold the timing. Cut the share short rather than letting it run; the disagreement is the point, not resolving it.</a:t>
             </a:r>
           </a:p>
           <a:p>
-            <a:endParaRPr/>
-          </a:p>
-          <a:p>
-            <a:r>
-              <a:t>- Banner colour: usually free — unless colour-blind users or a clinic house style make it consequential. Then tacit.</a:t>
-            </a:r>
-          </a:p>
-          <a:p>
-            <a:endParaRPr/>
-          </a:p>
-          <a:p>
-            <a:r>
+            <a:endParaRPr dirty="0"/>
+          </a:p>
+          <a:p>
+            <a:r>
+              <a:rPr dirty="0"/>
+              <a:t>- Banner color: usually free — unless color-blind users or a clinic house style make it consequential. Then tacit.</a:t>
+            </a:r>
+          </a:p>
+          <a:p>
+            <a:endParaRPr dirty="0"/>
+          </a:p>
+          <a:p>
+            <a:r>
+              <a:rPr dirty="0"/>
               <a:t>- Detection sensitivity: the clearest UNKNOWN candidate. We may not yet know what tradeoff users will tolerate between missed events and false alarms. The response is not to invent a number because a specification needs one. The response may be to learn.</a:t>
             </a:r>
           </a:p>
           <a:p>
-            <a:endParaRPr/>
-          </a:p>
-          <a:p>
-            <a:r>
+            <a:endParaRPr dirty="0"/>
+          </a:p>
+          <a:p>
+            <a:r>
+              <a:rPr dirty="0"/>
               <a:t>- Database: usually free — unless hosting location is regulated, in which case tacit.</a:t>
             </a:r>
           </a:p>
           <a:p>
-            <a:endParaRPr/>
-          </a:p>
-          <a:p>
-            <a:r>
+            <a:endParaRPr dirty="0"/>
+          </a:p>
+          <a:p>
+            <a:r>
+              <a:rPr dirty="0"/>
               <a:t>- Bounced mail: almost always tacit, and the most interesting one. Nobody wrote down that the user must find out.</a:t>
             </a:r>
           </a:p>
           <a:p>
-            <a:endParaRPr/>
-          </a:p>
-          <a:p>
-            <a:r>
+            <a:endParaRPr dirty="0"/>
+          </a:p>
+          <a:p>
+            <a:r>
+              <a:rPr dirty="0"/>
               <a:t>- Ask what additional context would change their classification. That question is the learning objective.</a:t>
             </a:r>
           </a:p>
           <a:p>
-            <a:endParaRPr/>
-          </a:p>
-          <a:p>
-            <a:r>
+            <a:endParaRPr dirty="0"/>
+          </a:p>
+          <a:p>
+            <a:r>
+              <a:rPr dirty="0"/>
               <a:t>=====</a:t>
             </a:r>
           </a:p>
           <a:p>
-            <a:endParaRPr/>
-          </a:p>
-          <a:p>
-            <a:r>
-              <a:t>One minute alone, then two with a neighbour. Argue for a classification, then say what additional context would change your classification.</a:t>
-            </a:r>
-          </a:p>
-          <a:p>
-            <a:endParaRPr/>
-          </a:p>
-          <a:p>
-            <a:r>
+            <a:endParaRPr dirty="0"/>
+          </a:p>
+          <a:p>
+            <a:r>
+              <a:rPr dirty="0"/>
+              <a:t>One minute alone, then two with a neighbor. Argue for a classification, then say what additional context would change your classification.</a:t>
+            </a:r>
+          </a:p>
+          <a:p>
+            <a:endParaRPr dirty="0"/>
+          </a:p>
+          <a:p>
+            <a:r>
+              <a:rPr dirty="0"/>
               <a:t>Take answers on the last one first — it produces the strongest disagreement. Then close: where you disagreed is where the engineering is. The label depends on what the system owes people, not on the words in the document.</a:t>
             </a:r>
           </a:p>
           <a:p>
-            <a:endParaRPr/>
-          </a:p>
-          <a:p>
-            <a:r>
+            <a:endParaRPr dirty="0"/>
+          </a:p>
+          <a:p>
+            <a:r>
+              <a:rPr dirty="0"/>
               <a:t>One of those cases is worth following. Suppose we decide the bounced-email behavior wasn't free at all—it was tacit.</a:t>
             </a:r>
           </a:p>
@@ -2168,86 +2190,105 @@
           <a:lstStyle/>
           <a:p>
             <a:r>
+              <a:rPr dirty="0"/>
               <a:t>2.5 minutes — Show that agents change the economics of omitted context, not the nature of specification.</a:t>
             </a:r>
           </a:p>
           <a:p>
-            <a:endParaRPr/>
-          </a:p>
-          <a:p>
-            <a:r>
+            <a:endParaRPr dirty="0"/>
+          </a:p>
+          <a:p>
+            <a:r>
+              <a:rPr dirty="0"/>
               <a:t>- This slide is about the TACIT category specifically. The general freedom argument is already made; do not repeat it.</a:t>
             </a:r>
           </a:p>
           <a:p>
-            <a:endParaRPr/>
-          </a:p>
-          <a:p>
-            <a:r>
+            <a:endParaRPr dirty="0"/>
+          </a:p>
+          <a:p>
+            <a:r>
+              <a:rPr dirty="0"/>
               <a:t>- Candidate D callback: the specification appears to permit D, an agent builds it, a human objects — and the objection IS the unrepresented obligation.</a:t>
             </a:r>
           </a:p>
           <a:p>
-            <a:endParaRPr/>
-          </a:p>
-          <a:p>
-            <a:r>
+            <a:endParaRPr dirty="0"/>
+          </a:p>
+          <a:p>
+            <a:r>
+              <a:rPr dirty="0"/>
               <a:t>- Keep it concrete and lightly funny. Avoid generic AI alarmism.</a:t>
             </a:r>
           </a:p>
           <a:p>
-            <a:endParaRPr/>
-          </a:p>
-          <a:p>
-            <a:r>
+            <a:endParaRPr dirty="0"/>
+          </a:p>
+          <a:p>
+            <a:r>
+              <a:rPr dirty="0"/>
               <a:t>=====</a:t>
             </a:r>
           </a:p>
           <a:p>
-            <a:endParaRPr/>
-          </a:p>
-          <a:p>
-            <a:r>
+            <a:endParaRPr dirty="0"/>
+          </a:p>
+          <a:p>
+            <a:r>
+              <a:rPr dirty="0"/>
               <a:t>Return to R7 one last time. Earlier you tried to decide what an implementor would need to know. Here is what happens when one of those consequential facts stays in someone's head.</a:t>
             </a:r>
           </a:p>
           <a:p>
-            <a:endParaRPr/>
-          </a:p>
-          <a:p>
-            <a:r>
+            <a:endParaRPr dirty="0"/>
+          </a:p>
+          <a:p>
+            <a:r>
+              <a:rPr dirty="0"/>
               <a:t>A teammate who sits near you gets a bounced mail and tells the user, because obviously. An agent gets a bounced mail, logs a warning, and returns success. Nothing in R7 forbids that.</a:t>
             </a:r>
           </a:p>
           <a:p>
-            <a:endParaRPr/>
-          </a:p>
-          <a:p>
-            <a:r>
-              <a:t>That objection — obviously not that — is the sound of an obligation nobody externalised. It was real; it just was not written anywhere.</a:t>
-            </a:r>
-          </a:p>
-          <a:p>
-            <a:endParaRPr/>
-          </a:p>
-          <a:p>
-            <a:r>
+            <a:endParaRPr dirty="0"/>
+          </a:p>
+          <a:p>
+            <a:r>
+              <a:rPr dirty="0"/>
+              <a:t>That objection — obviously not that — is the sound of an obligation nobody </a:t>
+            </a:r>
+            <a:r>
+              <a:rPr dirty="0" err="1"/>
+              <a:t>externalised</a:t>
+            </a:r>
+            <a:r>
+              <a:rPr dirty="0"/>
+              <a:t>. It was real; it just was not written anywhere.</a:t>
+            </a:r>
+          </a:p>
+          <a:p>
+            <a:endParaRPr dirty="0"/>
+          </a:p>
+          <a:p>
+            <a:r>
+              <a:rPr dirty="0"/>
               <a:t>The agent is not stupid, it is unopinionated. It will pick a locally plausible point in the apparent realization space every time you leave one open. A human who shares your context reconstructed the missing constraint for free — and we never noticed we were relying on that.</a:t>
             </a:r>
           </a:p>
           <a:p>
-            <a:endParaRPr/>
-          </a:p>
-          <a:p>
-            <a:r>
+            <a:endParaRPr dirty="0"/>
+          </a:p>
+          <a:p>
+            <a:r>
+              <a:rPr dirty="0"/>
               <a:t>Say aloud rather than showing: the agent does not share the team's unstated context, and what changed is the cost of leaving context unsaid.</a:t>
             </a:r>
           </a:p>
           <a:p>
-            <a:endParaRPr/>
-          </a:p>
-          <a:p>
-            <a:r>
+            <a:endParaRPr dirty="0"/>
+          </a:p>
+          <a:p>
+            <a:r>
+              <a:rPr dirty="0"/>
               <a:t>So why not eliminate this problem by specifying everything? Because constraints have a cost too—and software changes the economics of when we need to commit.</a:t>
             </a:r>
           </a:p>
@@ -2313,7 +2354,7 @@
           <a:p>
             <a:r>
               <a:rPr lang="en-US" dirty="0"/>
-              <a:t>So there is a tempting conclusion: </a:t>
+              <a:t>So, there is a tempting conclusion: </a:t>
             </a:r>
             <a:r>
               <a:rPr lang="en-US" b="1" dirty="0"/>
@@ -2342,6 +2383,9 @@
             </a:r>
           </a:p>
           <a:p>
+            <a:endParaRPr lang="en-US" dirty="0"/>
+          </a:p>
+          <a:p>
             <a:r>
               <a:rPr lang="en-US" dirty="0"/>
               <a:t>But there is a problem. </a:t>
@@ -2367,7 +2411,7 @@
           <a:p>
             <a:r>
               <a:rPr lang="en-US" dirty="0"/>
-              <a:t>So this last section asks when implementation should follow specification—and when implementation can help us </a:t>
+              <a:t>So, this last section asks when implementation should follow specification—and when implementation can help us </a:t>
             </a:r>
             <a:r>
               <a:rPr lang="en-US" i="1" dirty="0"/>
@@ -2512,86 +2556,105 @@
           <a:lstStyle/>
           <a:p>
             <a:r>
+              <a:rPr dirty="0"/>
               <a:t>2.5 minutes — Convert iteration from a scheduling habit into an epistemic claim.</a:t>
             </a:r>
           </a:p>
           <a:p>
-            <a:endParaRPr/>
-          </a:p>
-          <a:p>
-            <a:r>
+            <a:endParaRPr dirty="0"/>
+          </a:p>
+          <a:p>
+            <a:r>
+              <a:rPr dirty="0"/>
               <a:t>- Second half of a pair with the not-constrained-is-not-free slide: that carried the principle, this is the story. Tell it once.</a:t>
             </a:r>
           </a:p>
           <a:p>
-            <a:endParaRPr/>
-          </a:p>
-          <a:p>
-            <a:r>
+            <a:endParaRPr dirty="0"/>
+          </a:p>
+          <a:p>
+            <a:r>
+              <a:rPr dirty="0"/>
               <a:t>- This is the UNKNOWN case: the requirement (R5) was known from the beginning; the right specification of it was not.</a:t>
             </a:r>
           </a:p>
           <a:p>
-            <a:endParaRPr/>
-          </a:p>
-          <a:p>
-            <a:r>
+            <a:endParaRPr dirty="0"/>
+          </a:p>
+          <a:p>
+            <a:r>
+              <a:rPr dirty="0"/>
               <a:t>- The state model already made REBASELINING explicit; this story is about learning that the boundary we specified for it was drawn wrong.</a:t>
             </a:r>
           </a:p>
           <a:p>
-            <a:endParaRPr/>
-          </a:p>
-          <a:p>
-            <a:r>
+            <a:endParaRPr dirty="0"/>
+          </a:p>
+          <a:p>
+            <a:r>
+              <a:rPr dirty="0"/>
               <a:t>=====</a:t>
             </a:r>
           </a:p>
           <a:p>
-            <a:endParaRPr/>
-          </a:p>
-          <a:p>
-            <a:r>
-              <a:t>Go back to R5. We knew from the beginning that the app must adapt when a user's normal changes. So the problem here is not that we forgot the requirement.</a:t>
-            </a:r>
-          </a:p>
-          <a:p>
-            <a:endParaRPr/>
-          </a:p>
-          <a:p>
-            <a:r>
+            <a:endParaRPr dirty="0"/>
+          </a:p>
+          <a:p>
+            <a:r>
+              <a:rPr dirty="0"/>
+              <a:t>Go back to R5. We knew from the beginning that the app must adapt when a user's normal changes. So</a:t>
+            </a:r>
+            <a:r>
+              <a:rPr lang="en-US" dirty="0"/>
+              <a:t>, </a:t>
+            </a:r>
+            <a:r>
+              <a:rPr dirty="0"/>
+              <a:t>the problem here is not that we forgot the requirement.</a:t>
+            </a:r>
+          </a:p>
+          <a:p>
+            <a:endParaRPr dirty="0"/>
+          </a:p>
+          <a:p>
+            <a:r>
+              <a:rPr dirty="0"/>
               <a:t>The problem is that knowing the requirement does not mean we already know the right specification. Suppose we decide that a sufficiently persistent shift should cause the system to establish a new baseline. We build that rule and put it into use.</a:t>
             </a:r>
           </a:p>
           <a:p>
-            <a:endParaRPr/>
-          </a:p>
-          <a:p>
-            <a:r>
+            <a:endParaRPr dirty="0"/>
+          </a:p>
+          <a:p>
+            <a:r>
+              <a:rPr dirty="0"/>
               <a:t>Then observation teaches us that persistence alone does not capture the distinction we actually care about. The implementation may have done exactly what the specification required. What changed was our understanding of the acceptable boundary.</a:t>
             </a:r>
           </a:p>
           <a:p>
-            <a:endParaRPr/>
-          </a:p>
-          <a:p>
-            <a:r>
+            <a:endParaRPr dirty="0"/>
+          </a:p>
+          <a:p>
+            <a:r>
+              <a:rPr dirty="0"/>
               <a:t>This is the UNKNOWN case from a few slides ago. The answer was not to specify harder before we had evidence. We specified enough to proceed, built, observed, and learned.</a:t>
             </a:r>
           </a:p>
           <a:p>
-            <a:endParaRPr/>
-          </a:p>
-          <a:p>
-            <a:r>
+            <a:endParaRPr dirty="0"/>
+          </a:p>
+          <a:p>
+            <a:r>
+              <a:rPr dirty="0"/>
               <a:t>Do not turn this into an anti-specification argument. R5 remained valid. What changed was our specification of how that requirement should be realized.</a:t>
             </a:r>
           </a:p>
           <a:p>
-            <a:endParaRPr/>
-          </a:p>
-          <a:p>
-            <a:r>
+            <a:endParaRPr dirty="0"/>
+          </a:p>
+          <a:p>
+            <a:r>
+              <a:rPr dirty="0"/>
               <a:t>That gives us the third response to an unsettled choice: not constrain, not leave open—explore.</a:t>
             </a:r>
           </a:p>
@@ -2788,7 +2851,15 @@
           <a:p>
             <a:r>
               <a:rPr dirty="0"/>
-              <a:t>Leave open when every answer is acceptable. Say so in writing if you can — marking something deliberately open stops the next reader treating it as an oversight, and stops an agent treating it as an invitation.</a:t>
+              <a:t>Leave open when every answer is acceptable. Say so in writing if you can — marking something deliberately open stops the next reader treating it as an oversight</a:t>
+            </a:r>
+            <a:r>
+              <a:rPr lang="en-US" dirty="0"/>
+              <a:t> </a:t>
+            </a:r>
+            <a:r>
+              <a:rPr dirty="0"/>
+              <a:t>and stops an agent treating it as an invitation.</a:t>
             </a:r>
           </a:p>
           <a:p>
@@ -2855,7 +2926,7 @@
 </p:notes>
 </file>
 
-<file path=ppt/notesSlides/notesSlide32.xml><?xml version="1.0" encoding="utf-8"?>
+<file path=ppt/notesSlides/notesSlide31.xml><?xml version="1.0" encoding="utf-8"?>
 <p:notes xmlns:a="http://schemas.openxmlformats.org/drawingml/2006/main" xmlns:r="http://schemas.openxmlformats.org/officeDocument/2006/relationships" xmlns:p="http://schemas.openxmlformats.org/presentationml/2006/main">
   <p:cSld>
     <p:spTree>
@@ -2888,110 +2959,140 @@
           <a:lstStyle/>
           <a:p>
             <a:r>
+              <a:rPr dirty="0"/>
               <a:t>2 minutes — Close by locating today inside the course, and correct the ladder misconception.</a:t>
             </a:r>
           </a:p>
           <a:p>
-            <a:endParaRPr/>
-          </a:p>
-          <a:p>
-            <a:r>
-              <a:t>- It is the model from slide 2, extended forward. Students should recognise it instantly.</a:t>
-            </a:r>
-          </a:p>
-          <a:p>
-            <a:endParaRPr/>
-          </a:p>
-          <a:p>
-            <a:r>
+            <a:endParaRPr dirty="0"/>
+          </a:p>
+          <a:p>
+            <a:r>
+              <a:rPr dirty="0"/>
+              <a:t>- It is the model from slide 2, extended forward. Students should </a:t>
+            </a:r>
+            <a:r>
+              <a:rPr dirty="0" err="1"/>
+              <a:t>recognise</a:t>
+            </a:r>
+            <a:r>
+              <a:rPr dirty="0"/>
+              <a:t> it instantly.</a:t>
+            </a:r>
+          </a:p>
+          <a:p>
+            <a:endParaRPr dirty="0"/>
+          </a:p>
+          <a:p>
+            <a:r>
+              <a:rPr dirty="0"/>
               <a:t>- Architecture and design hang under A, not under SPECIFICATION. That is the argument.</a:t>
             </a:r>
           </a:p>
           <a:p>
-            <a:endParaRPr/>
-          </a:p>
-          <a:p>
-            <a:r>
+            <a:endParaRPr dirty="0"/>
+          </a:p>
+          <a:p>
+            <a:r>
+              <a:rPr dirty="0"/>
               <a:t>- Students picture requirements to design as one ladder of increasing detail. If architecture were more specification, every architectural decision would be an obligation on the implementor — which is not how anyone works.</a:t>
             </a:r>
           </a:p>
           <a:p>
-            <a:endParaRPr/>
-          </a:p>
-          <a:p>
-            <a:r>
+            <a:endParaRPr dirty="0"/>
+          </a:p>
+          <a:p>
+            <a:r>
+              <a:rPr dirty="0"/>
               <a:t>- If over time: skip the second build and say the closing line.</a:t>
             </a:r>
           </a:p>
           <a:p>
-            <a:endParaRPr/>
-          </a:p>
-          <a:p>
-            <a:r>
+            <a:endParaRPr dirty="0"/>
+          </a:p>
+          <a:p>
+            <a:r>
+              <a:rPr dirty="0"/>
               <a:t>- Check: can they say why requirements alone may not be buildable, what a specification adds, why more than one representation, what a degree of freedom is, why unspecified is not free, why not specify everything, and how iteration discovers specification?</a:t>
             </a:r>
           </a:p>
           <a:p>
-            <a:endParaRPr/>
-          </a:p>
-          <a:p>
-            <a:r>
+            <a:endParaRPr dirty="0"/>
+          </a:p>
+          <a:p>
+            <a:r>
+              <a:rPr dirty="0"/>
               <a:t>=====</a:t>
             </a:r>
           </a:p>
           <a:p>
-            <a:endParaRPr/>
-          </a:p>
-          <a:p>
-            <a:r>
+            <a:endParaRPr dirty="0"/>
+          </a:p>
+          <a:p>
+            <a:r>
+              <a:rPr dirty="0"/>
               <a:t>We opened with this picture and we are closing with it. Requirements: what should be true. Specification: which realizations we are willing to accept. R4 allowed Builds A, B, and C until we stated more obligations. R6 became concrete when we defined the weekly-summary boundary. R5 remained a requirement even when use taught us to revise the specification.</a:t>
             </a:r>
           </a:p>
           <a:p>
-            <a:endParaRPr/>
-          </a:p>
-          <a:p>
-            <a:r>
+            <a:endParaRPr dirty="0"/>
+          </a:p>
+          <a:p>
+            <a:r>
+              <a:rPr dirty="0"/>
               <a:t>ANIMATE</a:t>
             </a:r>
           </a:p>
           <a:p>
-            <a:endParaRPr/>
-          </a:p>
-          <a:p>
-            <a:r>
-              <a:t>Architecture asks how the system is structured. Design asks how each part is realised inside. Both hang under one candidate.</a:t>
-            </a:r>
-          </a:p>
-          <a:p>
-            <a:endParaRPr/>
-          </a:p>
-          <a:p>
-            <a:r>
+            <a:endParaRPr dirty="0"/>
+          </a:p>
+          <a:p>
+            <a:r>
+              <a:rPr dirty="0"/>
+              <a:t>Architecture asks how the system is structured. Design asks how each part is </a:t>
+            </a:r>
+            <a:r>
+              <a:rPr dirty="0" err="1"/>
+              <a:t>realised</a:t>
+            </a:r>
+            <a:r>
+              <a:rPr dirty="0"/>
+              <a:t> inside. Both hang under one candidate.</a:t>
+            </a:r>
+          </a:p>
+          <a:p>
+            <a:endParaRPr dirty="0"/>
+          </a:p>
+          <a:p>
+            <a:r>
+              <a:rPr dirty="0"/>
               <a:t>ANIMATE</a:t>
             </a:r>
           </a:p>
           <a:p>
-            <a:endParaRPr/>
-          </a:p>
-          <a:p>
-            <a:r>
+            <a:endParaRPr dirty="0"/>
+          </a:p>
+          <a:p>
+            <a:r>
+              <a:rPr dirty="0"/>
               <a:t>They are mostly choices inside the acceptable space rather than further specification, though a specification can reach them, as the A-7E subset requirement did. We pick one of the systems the specification was already willing to accept, and then decide how to structure and build it.</a:t>
             </a:r>
           </a:p>
           <a:p>
-            <a:endParaRPr/>
-          </a:p>
-          <a:p>
-            <a:r>
+            <a:endParaRPr dirty="0"/>
+          </a:p>
+          <a:p>
+            <a:r>
+              <a:rPr dirty="0"/>
               <a:t>Today we asked which realizations are acceptable. Next we start choosing how one of those acceptable systems should be structured.</a:t>
             </a:r>
           </a:p>
           <a:p>
-            <a:endParaRPr/>
-          </a:p>
-          <a:p>
-            <a:r>
+            <a:endParaRPr dirty="0"/>
+          </a:p>
+          <a:p>
+            <a:r>
+              <a:rPr dirty="0"/>
               <a:t>Constrain what matters. Leave acceptable alternatives open. Explore what you do not yet understand.</a:t>
             </a:r>
           </a:p>
@@ -3084,62 +3185,70 @@
           <a:lstStyle/>
           <a:p>
             <a:r>
+              <a:rPr dirty="0"/>
               <a:t>2 minutes — Show that reasonable requirements can still admit substantially different realizations.</a:t>
             </a:r>
           </a:p>
           <a:p>
-            <a:endParaRPr/>
-          </a:p>
-          <a:p>
-            <a:r>
+            <a:endParaRPr dirty="0"/>
+          </a:p>
+          <a:p>
+            <a:r>
+              <a:rPr dirty="0"/>
               <a:t>- Slide 2 already framed the model; do not re-explain it. This slide makes the abstract arrow concrete.</a:t>
             </a:r>
           </a:p>
           <a:p>
-            <a:endParaRPr/>
-          </a:p>
-          <a:p>
-            <a:r>
+            <a:endParaRPr dirty="0"/>
+          </a:p>
+          <a:p>
+            <a:r>
+              <a:rPr dirty="0"/>
               <a:t>- Name these Build A, B and C out loud. The letters carry through the lecture; later slides eliminate them one at a time.</a:t>
             </a:r>
           </a:p>
           <a:p>
-            <a:endParaRPr/>
-          </a:p>
-          <a:p>
-            <a:r>
+            <a:endParaRPr dirty="0"/>
+          </a:p>
+          <a:p>
+            <a:r>
+              <a:rPr dirty="0"/>
               <a:t>- Ask the closing question and take two answers before moving on.</a:t>
             </a:r>
           </a:p>
           <a:p>
-            <a:endParaRPr/>
-          </a:p>
-          <a:p>
-            <a:r>
+            <a:endParaRPr dirty="0"/>
+          </a:p>
+          <a:p>
+            <a:r>
+              <a:rPr dirty="0"/>
               <a:t>=====</a:t>
             </a:r>
           </a:p>
           <a:p>
-            <a:endParaRPr/>
-          </a:p>
-          <a:p>
-            <a:r>
+            <a:endParaRPr dirty="0"/>
+          </a:p>
+          <a:p>
+            <a:r>
+              <a:rPr dirty="0"/>
               <a:t>Three teams receive exactly that sentence and nothing more. Team A captures a baseline once, at install, and compares last night to it, every morning. Team B keeps a rolling thirty-day baseline and sends a weekly digest. Team C runs a heart-rate variability model and only speaks up above ninety percent confidence.</a:t>
             </a:r>
           </a:p>
           <a:p>
-            <a:endParaRPr/>
-          </a:p>
-          <a:p>
-            <a:r>
+            <a:endParaRPr dirty="0"/>
+          </a:p>
+          <a:p>
+            <a:r>
+              <a:rPr dirty="0"/>
               <a:t>Every one of those satisfies the sentence. None of them is the same product. A user would notice immediately which one they had.</a:t>
             </a:r>
           </a:p>
           <a:p>
-            <a:endParaRPr/>
-          </a:p>
-          <a:p>
-            <a:r>
+            <a:endParaRPr dirty="0"/>
+          </a:p>
+          <a:p>
+            <a:r>
+              <a:rPr dirty="0"/>
               <a:t>So what does specification add that R4 did not tell us? Start with the boundary between the world we care about and the machine we can build.</a:t>
             </a:r>
           </a:p>
@@ -3395,79 +3504,97 @@
           <a:lstStyle/>
           <a:p>
             <a:r>
+              <a:rPr dirty="0"/>
               <a:t>5 minutes — Students discover that omissions differ in kind before we give them the vocabulary.</a:t>
             </a:r>
           </a:p>
           <a:p>
-            <a:endParaRPr/>
-          </a:p>
-          <a:p>
-            <a:r>
+            <a:endParaRPr dirty="0"/>
+          </a:p>
+          <a:p>
+            <a:r>
+              <a:rPr dirty="0"/>
               <a:t>- Hold the timing firmly: 1 think, 2 pair, 2 share. Do not let the share run — the payoff is three slides away.</a:t>
             </a:r>
           </a:p>
           <a:p>
-            <a:endParaRPr/>
-          </a:p>
-          <a:p>
-            <a:r>
+            <a:endParaRPr dirty="0"/>
+          </a:p>
+          <a:p>
+            <a:r>
+              <a:rPr dirty="0"/>
               <a:t>- Likely answers to Q1: send it, let them pick a doctor, pick a format. Q2: consent, retention, revocation, what counts as a summary, what if sending fails. Q3: transport, file format, styling.</a:t>
             </a:r>
           </a:p>
           <a:p>
-            <a:endParaRPr/>
-          </a:p>
-          <a:p>
-            <a:r>
+            <a:endParaRPr dirty="0"/>
+          </a:p>
+          <a:p>
+            <a:r>
+              <a:rPr dirty="0"/>
               <a:t>- Do NOT introduce unknown / tacit / free here. Students must wrestle with the question first.</a:t>
             </a:r>
           </a:p>
           <a:p>
-            <a:endParaRPr/>
-          </a:p>
-          <a:p>
-            <a:r>
+            <a:endParaRPr dirty="0"/>
+          </a:p>
+          <a:p>
+            <a:r>
+              <a:rPr dirty="0"/>
               <a:t>- Close with the line on screen; that is the transition, not a summary.</a:t>
             </a:r>
           </a:p>
           <a:p>
-            <a:endParaRPr/>
-          </a:p>
-          <a:p>
-            <a:r>
+            <a:endParaRPr dirty="0"/>
+          </a:p>
+          <a:p>
+            <a:r>
+              <a:rPr dirty="0"/>
               <a:t>=====</a:t>
             </a:r>
           </a:p>
           <a:p>
-            <a:endParaRPr/>
-          </a:p>
-          <a:p>
-            <a:r>
+            <a:endParaRPr dirty="0"/>
+          </a:p>
+          <a:p>
+            <a:r>
+              <a:rPr dirty="0"/>
               <a:t>Now take another requirement from the same system: R7. Imagine handing exactly this requirement to an implementor who has never met the user and cannot ask you anything. One minute alone: write what the implementation must do, then everything you would still need to know.</a:t>
             </a:r>
           </a:p>
           <a:p>
-            <a:endParaRPr/>
-          </a:p>
-          <a:p>
-            <a:r>
-              <a:t>Now two minutes with a neighbour. Compare your missing-facts lists and mark the ones you would be content to let the implementor decide.</a:t>
-            </a:r>
-          </a:p>
-          <a:p>
-            <a:endParaRPr/>
-          </a:p>
-          <a:p>
-            <a:r>
+            <a:endParaRPr dirty="0"/>
+          </a:p>
+          <a:p>
+            <a:r>
+              <a:rPr dirty="0"/>
+              <a:t>Now two minutes with a neighbor. Compare your missing-facts lists and mark the ones you would be content to let the implementor decide.</a:t>
+            </a:r>
+          </a:p>
+          <a:p>
+            <a:endParaRPr dirty="0"/>
+          </a:p>
+          <a:p>
+            <a:r>
+              <a:rPr dirty="0"/>
               <a:t>Take three or four answers. Push on any two people who disagreed about whether something could be left open — that disagreement is the seed of the next section.</a:t>
             </a:r>
           </a:p>
           <a:p>
-            <a:endParaRPr/>
-          </a:p>
-          <a:p>
-            <a:r>
-              <a:t>Then close: notice that not every missing fact has the same status. Some you could answer today and did not. Some we do not yet know how to answer. Some you genuinely do not care about. We will come back to that.</a:t>
+            <a:endParaRPr dirty="0"/>
+          </a:p>
+          <a:p>
+            <a:r>
+              <a:rPr dirty="0"/>
+              <a:t>Then close: notice that not every missing </a:t>
+            </a:r>
+            <a:r>
+              <a:rPr lang="en-US" dirty="0"/>
+              <a:t>fact is handled the same way</a:t>
+            </a:r>
+            <a:r>
+              <a:rPr dirty="0"/>
+              <a:t>. Some you could answer today and did not. Some we do not yet know how to answer. Some you genuinely do not care about. We will come back to that.</a:t>
             </a:r>
           </a:p>
         </p:txBody>
@@ -3525,16 +3652,19 @@
           <a:lstStyle/>
           <a:p>
             <a:r>
+              <a:rPr dirty="0"/>
               <a:t>You just tried this for one requirement in a much smaller system. What happens when engineers have to answer the same question for a much more complex system?</a:t>
             </a:r>
           </a:p>
           <a:p>
             <a:r>
+              <a:rPr dirty="0"/>
               <a:t>Let's look at one substantial example: the A-7E aircraft software specification.</a:t>
             </a:r>
           </a:p>
           <a:p>
             <a:r>
+              <a:rPr dirty="0"/>
               <a:t>Do not read it as a historical curiosity, and do not look for one particular specification notation. Instead ask: what did these engineers decide needed to be made explicit, and how did they represent it?</a:t>
             </a:r>
           </a:p>
@@ -10511,7 +10641,7 @@
         </p:spPr>
         <p:txBody>
           <a:bodyPr wrap="square" lIns="0" tIns="0" rIns="0" bIns="0" anchor="t">
-            <a:normAutofit/>
+            <a:normAutofit fontScale="92500"/>
           </a:bodyPr>
           <a:lstStyle/>
           <a:p>
@@ -12500,7 +12630,7 @@
         </p:nvSpPr>
         <p:spPr>
           <a:xfrm>
-            <a:off x="2108200" y="1490472"/>
+            <a:off x="1515992" y="2524569"/>
             <a:ext cx="1524000" cy="658368"/>
           </a:xfrm>
           <a:prstGeom prst="rect">
@@ -12543,7 +12673,7 @@
         </p:nvSpPr>
         <p:spPr>
           <a:xfrm>
-            <a:off x="3937000" y="1490472"/>
+            <a:off x="3344792" y="2524569"/>
             <a:ext cx="1524000" cy="658368"/>
           </a:xfrm>
           <a:prstGeom prst="rect">
@@ -12586,7 +12716,7 @@
         </p:nvSpPr>
         <p:spPr>
           <a:xfrm>
-            <a:off x="3937000" y="3575304"/>
+            <a:off x="3344792" y="4609401"/>
             <a:ext cx="1524000" cy="658368"/>
           </a:xfrm>
           <a:prstGeom prst="rect">
@@ -12792,13 +12922,15 @@
       </p:sp>
       <p:cxnSp>
         <p:nvCxnSpPr>
-          <p:cNvPr id="1101" name="Flow"/>
-          <p:cNvCxnSpPr/>
+          <p:cNvPr id="1102" name="Flow"/>
+          <p:cNvCxnSpPr>
+            <a:cxnSpLocks/>
+          </p:cNvCxnSpPr>
           <p:nvPr/>
         </p:nvCxnSpPr>
         <p:spPr>
           <a:xfrm>
-            <a:off x="1803400" y="1819656"/>
+            <a:off x="3039992" y="2725737"/>
             <a:ext cx="304800" cy="0"/>
           </a:xfrm>
           <a:prstGeom prst="line">
@@ -12814,13 +12946,15 @@
       </p:cxnSp>
       <p:cxnSp>
         <p:nvCxnSpPr>
-          <p:cNvPr id="1102" name="Flow"/>
-          <p:cNvCxnSpPr/>
+          <p:cNvPr id="1120" name="Flow"/>
+          <p:cNvCxnSpPr>
+            <a:cxnSpLocks/>
+          </p:cNvCxnSpPr>
           <p:nvPr/>
         </p:nvCxnSpPr>
         <p:spPr>
-          <a:xfrm>
-            <a:off x="3632200" y="1691640"/>
+          <a:xfrm flipH="1">
+            <a:off x="3039992" y="3027489"/>
             <a:ext cx="304800" cy="0"/>
           </a:xfrm>
           <a:prstGeom prst="line">
@@ -12834,16 +12968,148 @@
           </a:ln>
         </p:spPr>
       </p:cxnSp>
+      <p:sp>
+        <p:nvSpPr>
+          <p:cNvPr id="1103" name="Lb"/>
+          <p:cNvSpPr txBox="1"/>
+          <p:nvPr/>
+        </p:nvSpPr>
+        <p:spPr>
+          <a:xfrm>
+            <a:off x="205207" y="2364232"/>
+            <a:ext cx="874981" cy="391160"/>
+          </a:xfrm>
+          <a:prstGeom prst="rect">
+            <a:avLst/>
+          </a:prstGeom>
+          <a:noFill/>
+          <a:ln>
+            <a:noFill/>
+          </a:ln>
+        </p:spPr>
+        <p:txBody>
+          <a:bodyPr lIns="0" tIns="0" rIns="0" bIns="0" anchor="ctr">
+            <a:noAutofit/>
+          </a:bodyPr>
+          <a:lstStyle/>
+          <a:p>
+            <a:pPr algn="ctr">
+              <a:buNone/>
+            </a:pPr>
+            <a:r>
+              <a:rPr lang="en-US" sz="1200" dirty="0">
+                <a:solidFill>
+                  <a:srgbClr val="555960"/>
+                </a:solidFill>
+              </a:rPr>
+              <a:t>baseline established</a:t>
+            </a:r>
+          </a:p>
+        </p:txBody>
+      </p:sp>
+      <p:sp>
+        <p:nvSpPr>
+          <p:cNvPr id="1121" name="Lb"/>
+          <p:cNvSpPr txBox="1"/>
+          <p:nvPr/>
+        </p:nvSpPr>
+        <p:spPr>
+          <a:xfrm>
+            <a:off x="2672650" y="3205421"/>
+            <a:ext cx="977358" cy="502863"/>
+          </a:xfrm>
+          <a:prstGeom prst="rect">
+            <a:avLst/>
+          </a:prstGeom>
+          <a:noFill/>
+          <a:ln>
+            <a:noFill/>
+          </a:ln>
+        </p:spPr>
+        <p:txBody>
+          <a:bodyPr lIns="0" tIns="0" rIns="0" bIns="0" anchor="ctr">
+            <a:noAutofit/>
+          </a:bodyPr>
+          <a:lstStyle/>
+          <a:p>
+            <a:pPr algn="ctr">
+              <a:buNone/>
+            </a:pPr>
+            <a:r>
+              <a:rPr lang="en-US" sz="1200" dirty="0">
+                <a:solidFill>
+                  <a:srgbClr val="555960"/>
+                </a:solidFill>
+              </a:rPr>
+              <a:t>pattern returns to normal</a:t>
+            </a:r>
+          </a:p>
+        </p:txBody>
+      </p:sp>
+      <p:sp>
+        <p:nvSpPr>
+          <p:cNvPr id="1104" name="Lb"/>
+          <p:cNvSpPr txBox="1"/>
+          <p:nvPr/>
+        </p:nvSpPr>
+        <p:spPr>
+          <a:xfrm>
+            <a:off x="2333996" y="2148377"/>
+            <a:ext cx="1742190" cy="343172"/>
+          </a:xfrm>
+          <a:prstGeom prst="rect">
+            <a:avLst/>
+          </a:prstGeom>
+          <a:noFill/>
+          <a:ln>
+            <a:noFill/>
+          </a:ln>
+        </p:spPr>
+        <p:txBody>
+          <a:bodyPr lIns="0" tIns="0" rIns="0" bIns="0" anchor="ctr">
+            <a:noAutofit/>
+          </a:bodyPr>
+          <a:lstStyle/>
+          <a:p>
+            <a:pPr algn="ctr">
+              <a:buNone/>
+            </a:pPr>
+            <a:r>
+              <a:rPr lang="en-US" sz="1200" dirty="0">
+                <a:solidFill>
+                  <a:srgbClr val="555960"/>
+                </a:solidFill>
+              </a:rPr>
+              <a:t>meaningful </a:t>
+            </a:r>
+          </a:p>
+          <a:p>
+            <a:pPr algn="ctr">
+              <a:buNone/>
+            </a:pPr>
+            <a:r>
+              <a:rPr lang="en-US" sz="1200" dirty="0">
+                <a:solidFill>
+                  <a:srgbClr val="555960"/>
+                </a:solidFill>
+              </a:rPr>
+              <a:t>departure detected</a:t>
+            </a:r>
+          </a:p>
+        </p:txBody>
+      </p:sp>
       <p:cxnSp>
         <p:nvCxnSpPr>
-          <p:cNvPr id="1120" name="Flow"/>
-          <p:cNvCxnSpPr/>
+          <p:cNvPr id="1105" name="Flow"/>
+          <p:cNvCxnSpPr>
+            <a:cxnSpLocks/>
+          </p:cNvCxnSpPr>
           <p:nvPr/>
         </p:nvCxnSpPr>
         <p:spPr>
-          <a:xfrm flipH="1">
-            <a:off x="3632200" y="1993392"/>
-            <a:ext cx="304800" cy="0"/>
+          <a:xfrm>
+            <a:off x="4106792" y="3256089"/>
+            <a:ext cx="0" cy="1353312"/>
           </a:xfrm>
           <a:prstGeom prst="line">
             <a:avLst/>
@@ -12858,14 +13124,14 @@
       </p:cxnSp>
       <p:sp>
         <p:nvSpPr>
-          <p:cNvPr id="1103" name="Lb"/>
+          <p:cNvPr id="1106" name="Lb"/>
           <p:cNvSpPr txBox="1"/>
           <p:nvPr/>
         </p:nvSpPr>
         <p:spPr>
           <a:xfrm>
-            <a:off x="1155700" y="1170432"/>
-            <a:ext cx="1600200" cy="254000"/>
+            <a:off x="3271506" y="3894099"/>
+            <a:ext cx="757003" cy="502920"/>
           </a:xfrm>
           <a:prstGeom prst="rect">
             <a:avLst/>
@@ -12881,7 +13147,7 @@
           </a:bodyPr>
           <a:lstStyle/>
           <a:p>
-            <a:pPr algn="ctr">
+            <a:pPr algn="r">
               <a:buNone/>
             </a:pPr>
             <a:r>
@@ -12890,99 +13156,69 @@
                   <a:srgbClr val="555960"/>
                 </a:solidFill>
               </a:rPr>
-              <a:t>baseline established</a:t>
-            </a:r>
-          </a:p>
-        </p:txBody>
-      </p:sp>
-      <p:sp>
-        <p:nvSpPr>
-          <p:cNvPr id="1121" name="Lb"/>
-          <p:cNvSpPr txBox="1"/>
-          <p:nvPr/>
-        </p:nvSpPr>
-        <p:spPr>
-          <a:xfrm>
-            <a:off x="3017520" y="2267712"/>
-            <a:ext cx="1600200" cy="502920"/>
-          </a:xfrm>
-          <a:prstGeom prst="rect">
-            <a:avLst/>
-          </a:prstGeom>
-          <a:noFill/>
-          <a:ln>
-            <a:noFill/>
-          </a:ln>
-        </p:spPr>
-        <p:txBody>
-          <a:bodyPr lIns="0" tIns="0" rIns="0" bIns="0" anchor="ctr">
-            <a:noAutofit/>
-          </a:bodyPr>
-          <a:lstStyle/>
-          <a:p>
-            <a:pPr algn="ctr">
-              <a:buNone/>
-            </a:pPr>
-            <a:r>
-              <a:rPr lang="en-US" sz="1200" dirty="0">
-                <a:solidFill>
-                  <a:srgbClr val="555960"/>
-                </a:solidFill>
-              </a:rPr>
-              <a:t>pattern returns to normal</a:t>
-            </a:r>
-          </a:p>
-        </p:txBody>
-      </p:sp>
-      <p:sp>
-        <p:nvSpPr>
-          <p:cNvPr id="1104" name="Lb"/>
-          <p:cNvSpPr txBox="1"/>
-          <p:nvPr/>
-        </p:nvSpPr>
-        <p:spPr>
-          <a:xfrm>
-            <a:off x="2641600" y="1170432"/>
-            <a:ext cx="2286000" cy="254000"/>
-          </a:xfrm>
-          <a:prstGeom prst="rect">
-            <a:avLst/>
-          </a:prstGeom>
-          <a:noFill/>
-          <a:ln>
-            <a:noFill/>
-          </a:ln>
-        </p:spPr>
-        <p:txBody>
-          <a:bodyPr lIns="0" tIns="0" rIns="0" bIns="0" anchor="ctr">
-            <a:noAutofit/>
-          </a:bodyPr>
-          <a:lstStyle/>
-          <a:p>
-            <a:pPr algn="ctr">
-              <a:buNone/>
-            </a:pPr>
-            <a:r>
-              <a:rPr lang="en-US" sz="1200" dirty="0">
-                <a:solidFill>
-                  <a:srgbClr val="555960"/>
-                </a:solidFill>
-              </a:rPr>
-              <a:t>meaningful departure detected</a:t>
+              <a:t>change appears persistent</a:t>
             </a:r>
           </a:p>
         </p:txBody>
       </p:sp>
       <p:cxnSp>
         <p:nvCxnSpPr>
-          <p:cNvPr id="1105" name="Flow"/>
-          <p:cNvCxnSpPr/>
+          <p:cNvPr id="1107" name="Flow"/>
+          <p:cNvCxnSpPr>
+            <a:cxnSpLocks/>
+          </p:cNvCxnSpPr>
           <p:nvPr/>
         </p:nvCxnSpPr>
         <p:spPr>
           <a:xfrm>
-            <a:off x="4699000" y="2221992"/>
-            <a:ext cx="0" cy="1353312"/>
+            <a:off x="4106792" y="5267769"/>
+            <a:ext cx="0" cy="365760"/>
+          </a:xfrm>
+          <a:prstGeom prst="line">
+            <a:avLst/>
+          </a:prstGeom>
+          <a:ln w="19050">
+            <a:solidFill>
+              <a:srgbClr val="8E6F3E"/>
+            </a:solidFill>
+          </a:ln>
+        </p:spPr>
+      </p:cxnSp>
+      <p:cxnSp>
+        <p:nvCxnSpPr>
+          <p:cNvPr id="1108" name="Flow"/>
+          <p:cNvCxnSpPr>
+            <a:cxnSpLocks/>
+          </p:cNvCxnSpPr>
+          <p:nvPr/>
+        </p:nvCxnSpPr>
+        <p:spPr>
+          <a:xfrm flipH="1">
+            <a:off x="2277992" y="5633529"/>
+            <a:ext cx="1828800" cy="0"/>
+          </a:xfrm>
+          <a:prstGeom prst="line">
+            <a:avLst/>
+          </a:prstGeom>
+          <a:ln w="19050">
+            <a:solidFill>
+              <a:srgbClr val="8E6F3E"/>
+            </a:solidFill>
+          </a:ln>
+        </p:spPr>
+      </p:cxnSp>
+      <p:cxnSp>
+        <p:nvCxnSpPr>
+          <p:cNvPr id="1109" name="Flow"/>
+          <p:cNvCxnSpPr>
+            <a:cxnSpLocks/>
+          </p:cNvCxnSpPr>
+          <p:nvPr/>
+        </p:nvCxnSpPr>
+        <p:spPr>
+          <a:xfrm flipV="1">
+            <a:off x="2277992" y="3182937"/>
+            <a:ext cx="0" cy="2450592"/>
           </a:xfrm>
           <a:prstGeom prst="line">
             <a:avLst/>
@@ -12997,116 +13233,13 @@
       </p:cxnSp>
       <p:sp>
         <p:nvSpPr>
-          <p:cNvPr id="1106" name="Lb"/>
-          <p:cNvSpPr txBox="1"/>
-          <p:nvPr/>
-        </p:nvSpPr>
-        <p:spPr>
-          <a:xfrm>
-            <a:off x="2907792" y="2971800"/>
-            <a:ext cx="1664208" cy="502920"/>
-          </a:xfrm>
-          <a:prstGeom prst="rect">
-            <a:avLst/>
-          </a:prstGeom>
-          <a:noFill/>
-          <a:ln>
-            <a:noFill/>
-          </a:ln>
-        </p:spPr>
-        <p:txBody>
-          <a:bodyPr lIns="0" tIns="0" rIns="0" bIns="0" anchor="ctr">
-            <a:noAutofit/>
-          </a:bodyPr>
-          <a:lstStyle/>
-          <a:p>
-            <a:pPr algn="r">
-              <a:buNone/>
-            </a:pPr>
-            <a:r>
-              <a:rPr lang="en-US" sz="1200" dirty="0">
-                <a:solidFill>
-                  <a:srgbClr val="555960"/>
-                </a:solidFill>
-              </a:rPr>
-              <a:t>change appears persistent</a:t>
-            </a:r>
-          </a:p>
-        </p:txBody>
-      </p:sp>
-      <p:cxnSp>
-        <p:nvCxnSpPr>
-          <p:cNvPr id="1107" name="Flow"/>
-          <p:cNvCxnSpPr/>
-          <p:nvPr/>
-        </p:nvCxnSpPr>
-        <p:spPr>
-          <a:xfrm>
-            <a:off x="4699000" y="4233672"/>
-            <a:ext cx="0" cy="365760"/>
-          </a:xfrm>
-          <a:prstGeom prst="line">
-            <a:avLst/>
-          </a:prstGeom>
-          <a:ln w="19050">
-            <a:solidFill>
-              <a:srgbClr val="8E6F3E"/>
-            </a:solidFill>
-          </a:ln>
-        </p:spPr>
-      </p:cxnSp>
-      <p:cxnSp>
-        <p:nvCxnSpPr>
-          <p:cNvPr id="1108" name="Flow"/>
-          <p:cNvCxnSpPr/>
-          <p:nvPr/>
-        </p:nvCxnSpPr>
-        <p:spPr>
-          <a:xfrm flipH="1">
-            <a:off x="2870200" y="4599432"/>
-            <a:ext cx="1828800" cy="0"/>
-          </a:xfrm>
-          <a:prstGeom prst="line">
-            <a:avLst/>
-          </a:prstGeom>
-          <a:ln w="19050">
-            <a:solidFill>
-              <a:srgbClr val="8E6F3E"/>
-            </a:solidFill>
-          </a:ln>
-        </p:spPr>
-      </p:cxnSp>
-      <p:cxnSp>
-        <p:nvCxnSpPr>
-          <p:cNvPr id="1109" name="Flow"/>
-          <p:cNvCxnSpPr/>
-          <p:nvPr/>
-        </p:nvCxnSpPr>
-        <p:spPr>
-          <a:xfrm flipV="1">
-            <a:off x="2870200" y="2148840"/>
-            <a:ext cx="0" cy="2450592"/>
-          </a:xfrm>
-          <a:prstGeom prst="line">
-            <a:avLst/>
-          </a:prstGeom>
-          <a:ln w="19050">
-            <a:solidFill>
-              <a:srgbClr val="8E6F3E"/>
-            </a:solidFill>
-            <a:tailEnd type="triangle"/>
-          </a:ln>
-        </p:spPr>
-      </p:cxnSp>
-      <p:sp>
-        <p:nvSpPr>
           <p:cNvPr id="1110" name="Lb"/>
           <p:cNvSpPr txBox="1"/>
           <p:nvPr/>
         </p:nvSpPr>
         <p:spPr>
           <a:xfrm>
-            <a:off x="2997200" y="4663440"/>
+            <a:off x="2404992" y="5697537"/>
             <a:ext cx="2032000" cy="254000"/>
           </a:xfrm>
           <a:prstGeom prst="rect">
@@ -13167,6 +13300,38 @@
           </a:prstGeom>
         </p:spPr>
       </p:pic>
+      <p:cxnSp>
+        <p:nvCxnSpPr>
+          <p:cNvPr id="7" name="Elbow Connector 6">
+            <a:extLst>
+              <a:ext uri="{FF2B5EF4-FFF2-40B4-BE49-F238E27FC236}">
+                <a16:creationId xmlns:a16="http://schemas.microsoft.com/office/drawing/2014/main" id="{EFE52EF8-AAD5-C64F-F173-00BC6D39E3B8}"/>
+              </a:ext>
+            </a:extLst>
+          </p:cNvPr>
+          <p:cNvCxnSpPr>
+            <a:cxnSpLocks/>
+            <a:stCxn id="1002" idx="2"/>
+            <a:endCxn id="1003" idx="1"/>
+          </p:cNvCxnSpPr>
+          <p:nvPr/>
+        </p:nvCxnSpPr>
+        <p:spPr>
+          <a:xfrm rot="16200000" flipH="1">
+            <a:off x="926240" y="2264000"/>
+            <a:ext cx="704913" cy="474592"/>
+          </a:xfrm>
+          <a:prstGeom prst="bentConnector2">
+            <a:avLst/>
+          </a:prstGeom>
+          <a:ln w="19050">
+            <a:solidFill>
+              <a:srgbClr val="8E6F3E"/>
+            </a:solidFill>
+            <a:tailEnd type="triangle"/>
+          </a:ln>
+        </p:spPr>
+      </p:cxnSp>
     </p:spTree>
     <p:extLst>
       <p:ext uri="{BB962C8B-B14F-4D97-AF65-F5344CB8AC3E}">
@@ -14142,7 +14307,7 @@
         </p:spPr>
         <p:txBody>
           <a:bodyPr wrap="square" lIns="109728" tIns="82296" rIns="109728" bIns="82296" anchor="ctr">
-            <a:normAutofit lnSpcReduction="10000"/>
+            <a:normAutofit fontScale="92500" lnSpcReduction="10000"/>
           </a:bodyPr>
           <a:lstStyle/>
           <a:p>
@@ -14503,7 +14668,7 @@
         </p:spPr>
         <p:txBody>
           <a:bodyPr wrap="square" lIns="109728" tIns="82296" rIns="109728" bIns="82296" anchor="ctr">
-            <a:normAutofit/>
+            <a:normAutofit lnSpcReduction="10000"/>
           </a:bodyPr>
           <a:lstStyle/>
           <a:p>
@@ -14546,7 +14711,7 @@
         </p:spPr>
         <p:txBody>
           <a:bodyPr wrap="square" lIns="109728" tIns="82296" rIns="109728" bIns="82296" anchor="ctr">
-            <a:normAutofit/>
+            <a:normAutofit lnSpcReduction="10000"/>
           </a:bodyPr>
           <a:lstStyle/>
           <a:p>
@@ -14589,7 +14754,7 @@
         </p:spPr>
         <p:txBody>
           <a:bodyPr wrap="square" lIns="109728" tIns="82296" rIns="109728" bIns="82296" anchor="ctr">
-            <a:normAutofit/>
+            <a:normAutofit lnSpcReduction="10000"/>
           </a:bodyPr>
           <a:lstStyle/>
           <a:p>
@@ -14633,7 +14798,7 @@
         </p:spPr>
         <p:txBody>
           <a:bodyPr wrap="square" lIns="109728" tIns="82296" rIns="109728" bIns="82296" anchor="ctr">
-            <a:normAutofit/>
+            <a:normAutofit lnSpcReduction="10000"/>
           </a:bodyPr>
           <a:lstStyle/>
           <a:p>
@@ -16747,7 +16912,7 @@
         </p:spPr>
         <p:txBody>
           <a:bodyPr wrap="square" lIns="0" tIns="0" rIns="0" bIns="0" anchor="t">
-            <a:normAutofit/>
+            <a:normAutofit fontScale="92500"/>
           </a:bodyPr>
           <a:lstStyle/>
           <a:p>
@@ -17070,8 +17235,8 @@
         </p:nvSpPr>
         <p:spPr>
           <a:xfrm>
-            <a:off x="5969000" y="1574800"/>
-            <a:ext cx="2794000" cy="508000"/>
+            <a:off x="6096000" y="1524000"/>
+            <a:ext cx="2305050" cy="508000"/>
           </a:xfrm>
           <a:prstGeom prst="rect">
             <a:avLst/>
@@ -17611,7 +17776,20 @@
                   <a:srgbClr val="3A3A3A"/>
                 </a:solidFill>
               </a:rPr>
-              <a:t>Each dot is a distinct possible realization. The obligations bound a region; they do not pick a point inside it.</a:t>
+              <a:t>Each dot is a distinct possible realization. </a:t>
+            </a:r>
+          </a:p>
+          <a:p>
+            <a:pPr algn="ctr">
+              <a:buNone/>
+            </a:pPr>
+            <a:r>
+              <a:rPr lang="en-US" sz="1700" dirty="0">
+                <a:solidFill>
+                  <a:srgbClr val="3A3A3A"/>
+                </a:solidFill>
+              </a:rPr>
+              <a:t>The obligations bound a region; they do not pick a point inside it.</a:t>
             </a:r>
           </a:p>
         </p:txBody>
@@ -19902,6 +20080,36 @@
           </a:p>
         </p:txBody>
       </p:sp>
+      <p:pic>
+        <p:nvPicPr>
+          <p:cNvPr id="2" name="Think Pair Share banner" descr="Think, Pair, Share">
+            <a:extLst>
+              <a:ext uri="{FF2B5EF4-FFF2-40B4-BE49-F238E27FC236}">
+                <a16:creationId xmlns:a16="http://schemas.microsoft.com/office/drawing/2014/main" id="{F5C909AE-DDFD-E290-3EEC-E98335FEB2A2}"/>
+              </a:ext>
+            </a:extLst>
+          </p:cNvPr>
+          <p:cNvPicPr>
+            <a:picLocks noChangeAspect="1"/>
+          </p:cNvPicPr>
+          <p:nvPr/>
+        </p:nvPicPr>
+        <p:blipFill>
+          <a:blip r:embed="rId3"/>
+          <a:stretch>
+            <a:fillRect/>
+          </a:stretch>
+        </p:blipFill>
+        <p:spPr>
+          <a:xfrm>
+            <a:off x="2476500" y="1008825"/>
+            <a:ext cx="4191000" cy="1206500"/>
+          </a:xfrm>
+          <a:prstGeom prst="rect">
+            <a:avLst/>
+          </a:prstGeom>
+        </p:spPr>
+      </p:pic>
     </p:spTree>
     <p:extLst>
       <p:ext uri="{BB962C8B-B14F-4D97-AF65-F5344CB8AC3E}">
@@ -22026,7 +22234,7 @@
         </p:spPr>
         <p:txBody>
           <a:bodyPr wrap="square" lIns="109728" tIns="82296" rIns="109728" bIns="82296" anchor="t">
-            <a:normAutofit fontScale="92500"/>
+            <a:normAutofit/>
           </a:bodyPr>
           <a:lstStyle/>
           <a:p>
@@ -22329,7 +22537,7 @@
         </p:spPr>
         <p:txBody>
           <a:bodyPr>
-            <a:normAutofit fontScale="90000"/>
+            <a:normAutofit/>
           </a:bodyPr>
           <a:lstStyle/>
           <a:p>
@@ -23032,7 +23240,7 @@
 </p:sld>
 </file>
 
-<file path=ppt/slides/slide32.xml><?xml version="1.0" encoding="utf-8"?>
+<file path=ppt/slides/slide31.xml><?xml version="1.0" encoding="utf-8"?>
 <p:sld xmlns:a="http://schemas.openxmlformats.org/drawingml/2006/main" xmlns:r="http://schemas.openxmlformats.org/officeDocument/2006/relationships" xmlns:p="http://schemas.openxmlformats.org/presentationml/2006/main">
   <p:cSld>
     <p:spTree>
@@ -23110,7 +23318,7 @@
           <a:p>
             <a:fld id="{B7EB45DA-9A0D-DC49-8E02-F30A5DDC21C3}" type="slidenum">
               <a:rPr lang="en-US" smtClean="0"/>
-              <a:t>32</a:t>
+              <a:t>31</a:t>
             </a:fld>
             <a:endParaRPr lang="en-US"/>
           </a:p>
@@ -23299,7 +23507,7 @@
         </p:spPr>
         <p:txBody>
           <a:bodyPr wrap="square" lIns="0" tIns="0" rIns="0" bIns="0" anchor="t">
-            <a:normAutofit/>
+            <a:normAutofit lnSpcReduction="10000"/>
           </a:bodyPr>
           <a:lstStyle/>
           <a:p>
@@ -23342,7 +23550,7 @@
         </p:spPr>
         <p:txBody>
           <a:bodyPr wrap="square" lIns="109728" tIns="82296" rIns="109728" bIns="82296" anchor="ctr">
-            <a:normAutofit/>
+            <a:normAutofit lnSpcReduction="10000"/>
           </a:bodyPr>
           <a:lstStyle/>
           <a:p>
@@ -23385,7 +23593,7 @@
         </p:spPr>
         <p:txBody>
           <a:bodyPr wrap="square" lIns="109728" tIns="82296" rIns="109728" bIns="82296" anchor="ctr">
-            <a:normAutofit/>
+            <a:normAutofit lnSpcReduction="10000"/>
           </a:bodyPr>
           <a:lstStyle/>
           <a:p>
@@ -23428,7 +23636,7 @@
         </p:spPr>
         <p:txBody>
           <a:bodyPr wrap="square" lIns="109728" tIns="82296" rIns="109728" bIns="82296" anchor="ctr">
-            <a:normAutofit/>
+            <a:normAutofit lnSpcReduction="10000"/>
           </a:bodyPr>
           <a:lstStyle/>
           <a:p>
@@ -23623,7 +23831,7 @@
         </p:spPr>
         <p:txBody>
           <a:bodyPr wrap="square" lIns="109728" tIns="82296" rIns="109728" bIns="82296" anchor="ctr">
-            <a:normAutofit fontScale="85000" lnSpcReduction="10000"/>
+            <a:normAutofit fontScale="92500"/>
           </a:bodyPr>
           <a:lstStyle/>
           <a:p>
@@ -24482,7 +24690,7 @@
         </p:spPr>
         <p:txBody>
           <a:bodyPr wrap="square" lIns="109728" tIns="82296" rIns="109728" bIns="82296" anchor="ctr">
-            <a:normAutofit/>
+            <a:normAutofit fontScale="92500" lnSpcReduction="10000"/>
           </a:bodyPr>
           <a:lstStyle/>
           <a:p>
@@ -24533,7 +24741,7 @@
         </p:spPr>
         <p:txBody>
           <a:bodyPr wrap="square" lIns="109728" tIns="82296" rIns="109728" bIns="82296" anchor="ctr">
-            <a:normAutofit/>
+            <a:normAutofit fontScale="92500" lnSpcReduction="10000"/>
           </a:bodyPr>
           <a:lstStyle/>
           <a:p>
@@ -24584,7 +24792,7 @@
         </p:spPr>
         <p:txBody>
           <a:bodyPr wrap="square" lIns="109728" tIns="82296" rIns="109728" bIns="82296" anchor="ctr">
-            <a:normAutofit/>
+            <a:normAutofit fontScale="92500"/>
           </a:bodyPr>
           <a:lstStyle/>
           <a:p>
@@ -24686,7 +24894,7 @@
         </p:spPr>
         <p:txBody>
           <a:bodyPr wrap="square" lIns="109728" tIns="82296" rIns="109728" bIns="82296" anchor="ctr">
-            <a:normAutofit/>
+            <a:normAutofit fontScale="92500"/>
           </a:bodyPr>
           <a:lstStyle/>
           <a:p>
@@ -24737,7 +24945,7 @@
         </p:spPr>
         <p:txBody>
           <a:bodyPr wrap="square" lIns="109728" tIns="82296" rIns="109728" bIns="82296" anchor="ctr">
-            <a:normAutofit/>
+            <a:normAutofit fontScale="92500" lnSpcReduction="10000"/>
           </a:bodyPr>
           <a:lstStyle/>
           <a:p>
@@ -25459,15 +25667,19 @@
             <p:ph type="title"/>
           </p:nvPr>
         </p:nvSpPr>
-        <p:spPr/>
+        <p:spPr>
+          <a:xfrm>
+            <a:off x="277148" y="118428"/>
+            <a:ext cx="8324254" cy="638175"/>
+          </a:xfrm>
+        </p:spPr>
         <p:txBody>
           <a:bodyPr>
             <a:normAutofit fontScale="90000"/>
           </a:bodyPr>
           <a:lstStyle/>
           <a:p>
-            <a:pPr algn="l">
-              <a:buNone/>
+            <a:pPr>
               <a:defRPr b="0"/>
             </a:pPr>
             <a:r>
@@ -25476,8 +25688,21 @@
                   <a:srgbClr val="000000"/>
                 </a:solidFill>
               </a:rPr>
-              <a:t>Requirements ≠ specification</a:t>
-            </a:r>
+              <a:t>Requirements ≠ S</a:t>
+            </a:r>
+            <a:r>
+              <a:rPr lang="en-US" sz="3200" dirty="0">
+                <a:solidFill>
+                  <a:srgbClr val="000000"/>
+                </a:solidFill>
+              </a:rPr>
+              <a:t>pecification ≠ Machine instr.</a:t>
+            </a:r>
+            <a:endParaRPr lang="en-US" sz="3200" b="0" i="0" dirty="0">
+              <a:solidFill>
+                <a:srgbClr val="000000"/>
+              </a:solidFill>
+            </a:endParaRPr>
           </a:p>
         </p:txBody>
       </p:sp>
@@ -26948,7 +27173,12 @@
             <p:ph type="title"/>
           </p:nvPr>
         </p:nvSpPr>
-        <p:spPr/>
+        <p:spPr>
+          <a:xfrm>
+            <a:off x="277148" y="118428"/>
+            <a:ext cx="8559800" cy="638175"/>
+          </a:xfrm>
+        </p:spPr>
         <p:txBody>
           <a:bodyPr>
             <a:normAutofit fontScale="90000"/>
@@ -26965,7 +27195,7 @@
                   <a:srgbClr val="000000"/>
                 </a:solidFill>
               </a:rPr>
-              <a:t>What would you tell the implementor?</a:t>
+              <a:t>How would you constrain the machine (implementation)?</a:t>
             </a:r>
           </a:p>
         </p:txBody>
@@ -27015,8 +27245,8 @@
         </p:blipFill>
         <p:spPr>
           <a:xfrm>
-            <a:off x="279400" y="762000"/>
-            <a:ext cx="4191000" cy="1206500"/>
+            <a:off x="279400" y="797706"/>
+            <a:ext cx="4066969" cy="1170794"/>
           </a:xfrm>
           <a:prstGeom prst="rect">
             <a:avLst/>
@@ -27120,7 +27350,7 @@
         </p:spPr>
         <p:txBody>
           <a:bodyPr wrap="square" lIns="109728" tIns="82296" rIns="109728" bIns="82296" anchor="ctr">
-            <a:normAutofit/>
+            <a:normAutofit lnSpcReduction="10000"/>
           </a:bodyPr>
           <a:lstStyle/>
           <a:p>
@@ -27149,7 +27379,39 @@
                   <a:srgbClr val="000000"/>
                 </a:solidFill>
               </a:rPr>
-              <a:t>What must the app do?</a:t>
+              <a:t>What </a:t>
+            </a:r>
+            <a:r>
+              <a:rPr lang="en-US" sz="2200" b="1" dirty="0">
+                <a:solidFill>
+                  <a:srgbClr val="000000"/>
+                </a:solidFill>
+              </a:rPr>
+              <a:t>must</a:t>
+            </a:r>
+            <a:r>
+              <a:rPr lang="en-US" sz="2200" b="1" i="0" dirty="0">
+                <a:solidFill>
+                  <a:srgbClr val="000000"/>
+                </a:solidFill>
+              </a:rPr>
+              <a:t> the app do?</a:t>
+            </a:r>
+          </a:p>
+          <a:p>
+            <a:pPr algn="l">
+              <a:spcBef>
+                <a:spcPts val="160"/>
+              </a:spcBef>
+              <a:buNone/>
+            </a:pPr>
+            <a:r>
+              <a:rPr lang="en-US" i="1" dirty="0">
+                <a:solidFill>
+                  <a:srgbClr val="000000"/>
+                </a:solidFill>
+              </a:rPr>
+              <a:t>required behavior</a:t>
             </a:r>
           </a:p>
         </p:txBody>
@@ -27179,7 +27441,7 @@
         </p:spPr>
         <p:txBody>
           <a:bodyPr wrap="square" lIns="109728" tIns="82296" rIns="109728" bIns="82296" anchor="ctr">
-            <a:normAutofit/>
+            <a:normAutofit lnSpcReduction="10000"/>
           </a:bodyPr>
           <a:lstStyle/>
           <a:p>
@@ -27209,6 +27471,21 @@
                 </a:solidFill>
               </a:rPr>
               <a:t>What facts are missing?</a:t>
+            </a:r>
+          </a:p>
+          <a:p>
+            <a:pPr>
+              <a:spcBef>
+                <a:spcPts val="160"/>
+              </a:spcBef>
+            </a:pPr>
+            <a:r>
+              <a:rPr lang="en-US" i="1" dirty="0">
+                <a:solidFill>
+                  <a:srgbClr val="000000"/>
+                </a:solidFill>
+              </a:rPr>
+              <a:t>domain assumptions</a:t>
             </a:r>
           </a:p>
         </p:txBody>
@@ -27238,7 +27515,7 @@
         </p:spPr>
         <p:txBody>
           <a:bodyPr wrap="square" lIns="109728" tIns="82296" rIns="109728" bIns="82296" anchor="ctr">
-            <a:normAutofit/>
+            <a:normAutofit fontScale="85000" lnSpcReduction="10000"/>
           </a:bodyPr>
           <a:lstStyle/>
           <a:p>
@@ -27262,12 +27539,28 @@
               <a:buNone/>
             </a:pPr>
             <a:r>
-              <a:rPr lang="en-US" sz="2200" b="1" i="0" dirty="0">
+              <a:rPr lang="en-US" sz="2600" b="1" i="0" dirty="0">
                 <a:solidFill>
                   <a:srgbClr val="000000"/>
                 </a:solidFill>
               </a:rPr>
               <a:t>What can remain unspecified?</a:t>
+            </a:r>
+          </a:p>
+          <a:p>
+            <a:pPr algn="l">
+              <a:spcBef>
+                <a:spcPts val="160"/>
+              </a:spcBef>
+              <a:buNone/>
+            </a:pPr>
+            <a:r>
+              <a:rPr lang="en-US" sz="2100" i="1" dirty="0">
+                <a:solidFill>
+                  <a:srgbClr val="000000"/>
+                </a:solidFill>
+              </a:rPr>
+              <a:t>implementor may choose</a:t>
             </a:r>
           </a:p>
         </p:txBody>
@@ -27378,7 +27671,7 @@
                   <a:srgbClr val="000000"/>
                 </a:solidFill>
               </a:rPr>
-              <a:t>Not every missing fact has the same status.</a:t>
+              <a:t>Not every missing fact is handled the same way.</a:t>
             </a:r>
           </a:p>
         </p:txBody>
@@ -27707,7 +28000,7 @@
         </p:spPr>
         <p:txBody>
           <a:bodyPr wrap="square" lIns="109728" tIns="82296" rIns="109728" bIns="82296" anchor="ctr">
-            <a:normAutofit fontScale="92500"/>
+            <a:normAutofit/>
           </a:bodyPr>
           <a:lstStyle/>
           <a:p>
@@ -27902,7 +28195,7 @@
         </p:spPr>
         <p:txBody>
           <a:bodyPr wrap="square" lIns="109728" tIns="82296" rIns="109728" bIns="82296" anchor="ctr">
-            <a:normAutofit fontScale="85000" lnSpcReduction="10000"/>
+            <a:normAutofit/>
           </a:bodyPr>
           <a:lstStyle/>
           <a:p>

</xml_diff>